<commit_message>
docs: add ppt visual review workflow
</commit_message>
<xml_diff>
--- a/docs/slides/pycycle_ai_prompting_course.pptx
+++ b/docs/slides/pycycle_ai_prompting_course.pptx
@@ -5,29 +5,29 @@
     <p:sldMasterId id="2147483648" r:id="rId1"/>
   </p:sldMasterIdLst>
   <p:sldIdLst>
-    <p:sldId id="256" r:id="rId2"/>
-    <p:sldId id="257" r:id="rId3"/>
-    <p:sldId id="258" r:id="rId4"/>
-    <p:sldId id="259" r:id="rId5"/>
-    <p:sldId id="260" r:id="rId6"/>
-    <p:sldId id="261" r:id="rId7"/>
-    <p:sldId id="262" r:id="rId8"/>
-    <p:sldId id="263" r:id="rId9"/>
-    <p:sldId id="264" r:id="rId10"/>
-    <p:sldId id="265" r:id="rId11"/>
-    <p:sldId id="266" r:id="rId12"/>
-    <p:sldId id="267" r:id="rId13"/>
-    <p:sldId id="268" r:id="rId14"/>
-    <p:sldId id="269" r:id="rId15"/>
-    <p:sldId id="270" r:id="rId16"/>
-    <p:sldId id="271" r:id="rId17"/>
-    <p:sldId id="272" r:id="rId18"/>
-    <p:sldId id="273" r:id="rId19"/>
-    <p:sldId id="274" r:id="rId20"/>
-    <p:sldId id="275" r:id="rId21"/>
-    <p:sldId id="276" r:id="rId22"/>
+    <p:sldId id="256" r:id="rId7"/>
+    <p:sldId id="257" r:id="rId8"/>
+    <p:sldId id="258" r:id="rId9"/>
+    <p:sldId id="259" r:id="rId10"/>
+    <p:sldId id="260" r:id="rId11"/>
+    <p:sldId id="261" r:id="rId12"/>
+    <p:sldId id="262" r:id="rId13"/>
+    <p:sldId id="263" r:id="rId14"/>
+    <p:sldId id="264" r:id="rId15"/>
+    <p:sldId id="265" r:id="rId16"/>
+    <p:sldId id="266" r:id="rId17"/>
+    <p:sldId id="267" r:id="rId18"/>
+    <p:sldId id="268" r:id="rId19"/>
+    <p:sldId id="269" r:id="rId20"/>
+    <p:sldId id="270" r:id="rId21"/>
+    <p:sldId id="271" r:id="rId22"/>
+    <p:sldId id="272" r:id="rId23"/>
+    <p:sldId id="273" r:id="rId24"/>
+    <p:sldId id="274" r:id="rId25"/>
+    <p:sldId id="275" r:id="rId26"/>
+    <p:sldId id="276" r:id="rId27"/>
   </p:sldIdLst>
-  <p:sldSz cx="12192000" cy="6858000"/>
+  <p:sldSz cx="12191695" cy="6858000" type="screen4x3"/>
   <p:notesSz cx="6858000" cy="9144000"/>
   <p:defaultTextStyle>
     <a:defPPr>
@@ -124,22 +124,6 @@
       </a:defRPr>
     </a:lvl9pPr>
   </p:defaultTextStyle>
-  <p:extLst>
-    <p:ext uri="{EFAFB233-063F-42B5-8137-9DF3F51BA10A}">
-      <p15:sldGuideLst xmlns:p15="http://schemas.microsoft.com/office/powerpoint/2012/main">
-        <p15:guide id="1" orient="horz" pos="2160">
-          <p15:clr>
-            <a:srgbClr val="A4A3A4"/>
-          </p15:clr>
-        </p15:guide>
-        <p15:guide id="2" pos="2880">
-          <p15:clr>
-            <a:srgbClr val="A4A3A4"/>
-          </p15:clr>
-        </p15:guide>
-      </p15:sldGuideLst>
-    </p:ext>
-  </p:extLst>
 </p:presentation>
 </file>
 
@@ -181,9 +165,10 @@
           <a:lstStyle/>
           <a:p>
             <a:r>
-              <a:rPr lang="en-US"/>
+              <a:rPr lang="en-US" smtClean="0"/>
               <a:t>Click to edit Master title style</a:t>
             </a:r>
+            <a:endParaRPr lang="en-US"/>
           </a:p>
         </p:txBody>
       </p:sp>
@@ -299,9 +284,10 @@
           </a:lstStyle>
           <a:p>
             <a:r>
-              <a:rPr lang="en-US"/>
+              <a:rPr lang="en-US" smtClean="0"/>
               <a:t>Click to edit Master subtitle style</a:t>
             </a:r>
+            <a:endParaRPr lang="en-US"/>
           </a:p>
         </p:txBody>
       </p:sp>
@@ -322,7 +308,7 @@
           <a:p>
             <a:fld id="{5BCAD085-E8A6-8845-BD4E-CB4CCA059FC4}" type="datetimeFigureOut">
               <a:rPr lang="en-US" smtClean="0"/>
-              <a:t>5/11/2026</a:t>
+              <a:t>1/27/13</a:t>
             </a:fld>
             <a:endParaRPr lang="en-US"/>
           </a:p>
@@ -416,9 +402,10 @@
           <a:lstStyle/>
           <a:p>
             <a:r>
-              <a:rPr lang="en-US"/>
+              <a:rPr lang="en-US" smtClean="0"/>
               <a:t>Click to edit Master title style</a:t>
             </a:r>
+            <a:endParaRPr lang="en-US"/>
           </a:p>
         </p:txBody>
       </p:sp>
@@ -439,37 +426,38 @@
           <a:p>
             <a:pPr lvl="0"/>
             <a:r>
-              <a:rPr lang="en-US"/>
+              <a:rPr lang="en-US" smtClean="0"/>
               <a:t>Click to edit Master text styles</a:t>
             </a:r>
           </a:p>
           <a:p>
             <a:pPr lvl="1"/>
             <a:r>
-              <a:rPr lang="en-US"/>
+              <a:rPr lang="en-US" smtClean="0"/>
               <a:t>Second level</a:t>
             </a:r>
           </a:p>
           <a:p>
             <a:pPr lvl="2"/>
             <a:r>
-              <a:rPr lang="en-US"/>
+              <a:rPr lang="en-US" smtClean="0"/>
               <a:t>Third level</a:t>
             </a:r>
           </a:p>
           <a:p>
             <a:pPr lvl="3"/>
             <a:r>
-              <a:rPr lang="en-US"/>
+              <a:rPr lang="en-US" smtClean="0"/>
               <a:t>Fourth level</a:t>
             </a:r>
           </a:p>
           <a:p>
             <a:pPr lvl="4"/>
             <a:r>
-              <a:rPr lang="en-US"/>
+              <a:rPr lang="en-US" smtClean="0"/>
               <a:t>Fifth level</a:t>
             </a:r>
+            <a:endParaRPr lang="en-US"/>
           </a:p>
         </p:txBody>
       </p:sp>
@@ -490,7 +478,7 @@
           <a:p>
             <a:fld id="{5BCAD085-E8A6-8845-BD4E-CB4CCA059FC4}" type="datetimeFigureOut">
               <a:rPr lang="en-US" smtClean="0"/>
-              <a:t>5/11/2026</a:t>
+              <a:t>1/27/13</a:t>
             </a:fld>
             <a:endParaRPr lang="en-US"/>
           </a:p>
@@ -589,9 +577,10 @@
           <a:lstStyle/>
           <a:p>
             <a:r>
-              <a:rPr lang="en-US"/>
+              <a:rPr lang="en-US" smtClean="0"/>
               <a:t>Click to edit Master title style</a:t>
             </a:r>
+            <a:endParaRPr lang="en-US"/>
           </a:p>
         </p:txBody>
       </p:sp>
@@ -617,37 +606,38 @@
           <a:p>
             <a:pPr lvl="0"/>
             <a:r>
-              <a:rPr lang="en-US"/>
+              <a:rPr lang="en-US" smtClean="0"/>
               <a:t>Click to edit Master text styles</a:t>
             </a:r>
           </a:p>
           <a:p>
             <a:pPr lvl="1"/>
             <a:r>
-              <a:rPr lang="en-US"/>
+              <a:rPr lang="en-US" smtClean="0"/>
               <a:t>Second level</a:t>
             </a:r>
           </a:p>
           <a:p>
             <a:pPr lvl="2"/>
             <a:r>
-              <a:rPr lang="en-US"/>
+              <a:rPr lang="en-US" smtClean="0"/>
               <a:t>Third level</a:t>
             </a:r>
           </a:p>
           <a:p>
             <a:pPr lvl="3"/>
             <a:r>
-              <a:rPr lang="en-US"/>
+              <a:rPr lang="en-US" smtClean="0"/>
               <a:t>Fourth level</a:t>
             </a:r>
           </a:p>
           <a:p>
             <a:pPr lvl="4"/>
             <a:r>
-              <a:rPr lang="en-US"/>
+              <a:rPr lang="en-US" smtClean="0"/>
               <a:t>Fifth level</a:t>
             </a:r>
+            <a:endParaRPr lang="en-US"/>
           </a:p>
         </p:txBody>
       </p:sp>
@@ -668,7 +658,7 @@
           <a:p>
             <a:fld id="{5BCAD085-E8A6-8845-BD4E-CB4CCA059FC4}" type="datetimeFigureOut">
               <a:rPr lang="en-US" smtClean="0"/>
-              <a:t>5/11/2026</a:t>
+              <a:t>1/27/13</a:t>
             </a:fld>
             <a:endParaRPr lang="en-US"/>
           </a:p>
@@ -762,9 +752,10 @@
           <a:lstStyle/>
           <a:p>
             <a:r>
-              <a:rPr lang="en-US"/>
+              <a:rPr lang="en-US" smtClean="0"/>
               <a:t>Click to edit Master title style</a:t>
             </a:r>
+            <a:endParaRPr lang="en-US"/>
           </a:p>
         </p:txBody>
       </p:sp>
@@ -785,37 +776,38 @@
           <a:p>
             <a:pPr lvl="0"/>
             <a:r>
-              <a:rPr lang="en-US"/>
+              <a:rPr lang="en-US" smtClean="0"/>
               <a:t>Click to edit Master text styles</a:t>
             </a:r>
           </a:p>
           <a:p>
             <a:pPr lvl="1"/>
             <a:r>
-              <a:rPr lang="en-US"/>
+              <a:rPr lang="en-US" smtClean="0"/>
               <a:t>Second level</a:t>
             </a:r>
           </a:p>
           <a:p>
             <a:pPr lvl="2"/>
             <a:r>
-              <a:rPr lang="en-US"/>
+              <a:rPr lang="en-US" smtClean="0"/>
               <a:t>Third level</a:t>
             </a:r>
           </a:p>
           <a:p>
             <a:pPr lvl="3"/>
             <a:r>
-              <a:rPr lang="en-US"/>
+              <a:rPr lang="en-US" smtClean="0"/>
               <a:t>Fourth level</a:t>
             </a:r>
           </a:p>
           <a:p>
             <a:pPr lvl="4"/>
             <a:r>
-              <a:rPr lang="en-US"/>
+              <a:rPr lang="en-US" smtClean="0"/>
               <a:t>Fifth level</a:t>
             </a:r>
+            <a:endParaRPr lang="en-US"/>
           </a:p>
         </p:txBody>
       </p:sp>
@@ -836,7 +828,7 @@
           <a:p>
             <a:fld id="{5BCAD085-E8A6-8845-BD4E-CB4CCA059FC4}" type="datetimeFigureOut">
               <a:rPr lang="en-US" smtClean="0"/>
-              <a:t>5/11/2026</a:t>
+              <a:t>1/27/13</a:t>
             </a:fld>
             <a:endParaRPr lang="en-US"/>
           </a:p>
@@ -939,9 +931,10 @@
           </a:lstStyle>
           <a:p>
             <a:r>
-              <a:rPr lang="en-US"/>
+              <a:rPr lang="en-US" smtClean="0"/>
               <a:t>Click to edit Master title style</a:t>
             </a:r>
+            <a:endParaRPr lang="en-US"/>
           </a:p>
         </p:txBody>
       </p:sp>
@@ -1058,7 +1051,7 @@
           <a:p>
             <a:pPr lvl="0"/>
             <a:r>
-              <a:rPr lang="en-US"/>
+              <a:rPr lang="en-US" smtClean="0"/>
               <a:t>Click to edit Master text styles</a:t>
             </a:r>
           </a:p>
@@ -1081,7 +1074,7 @@
           <a:p>
             <a:fld id="{5BCAD085-E8A6-8845-BD4E-CB4CCA059FC4}" type="datetimeFigureOut">
               <a:rPr lang="en-US" smtClean="0"/>
-              <a:t>5/11/2026</a:t>
+              <a:t>1/27/13</a:t>
             </a:fld>
             <a:endParaRPr lang="en-US"/>
           </a:p>
@@ -1175,9 +1168,10 @@
           <a:lstStyle/>
           <a:p>
             <a:r>
-              <a:rPr lang="en-US"/>
+              <a:rPr lang="en-US" smtClean="0"/>
               <a:t>Click to edit Master title style</a:t>
             </a:r>
+            <a:endParaRPr lang="en-US"/>
           </a:p>
         </p:txBody>
       </p:sp>
@@ -1231,37 +1225,38 @@
           <a:p>
             <a:pPr lvl="0"/>
             <a:r>
-              <a:rPr lang="en-US"/>
+              <a:rPr lang="en-US" smtClean="0"/>
               <a:t>Click to edit Master text styles</a:t>
             </a:r>
           </a:p>
           <a:p>
             <a:pPr lvl="1"/>
             <a:r>
-              <a:rPr lang="en-US"/>
+              <a:rPr lang="en-US" smtClean="0"/>
               <a:t>Second level</a:t>
             </a:r>
           </a:p>
           <a:p>
             <a:pPr lvl="2"/>
             <a:r>
-              <a:rPr lang="en-US"/>
+              <a:rPr lang="en-US" smtClean="0"/>
               <a:t>Third level</a:t>
             </a:r>
           </a:p>
           <a:p>
             <a:pPr lvl="3"/>
             <a:r>
-              <a:rPr lang="en-US"/>
+              <a:rPr lang="en-US" smtClean="0"/>
               <a:t>Fourth level</a:t>
             </a:r>
           </a:p>
           <a:p>
             <a:pPr lvl="4"/>
             <a:r>
-              <a:rPr lang="en-US"/>
+              <a:rPr lang="en-US" smtClean="0"/>
               <a:t>Fifth level</a:t>
             </a:r>
+            <a:endParaRPr lang="en-US"/>
           </a:p>
         </p:txBody>
       </p:sp>
@@ -1315,37 +1310,38 @@
           <a:p>
             <a:pPr lvl="0"/>
             <a:r>
-              <a:rPr lang="en-US"/>
+              <a:rPr lang="en-US" smtClean="0"/>
               <a:t>Click to edit Master text styles</a:t>
             </a:r>
           </a:p>
           <a:p>
             <a:pPr lvl="1"/>
             <a:r>
-              <a:rPr lang="en-US"/>
+              <a:rPr lang="en-US" smtClean="0"/>
               <a:t>Second level</a:t>
             </a:r>
           </a:p>
           <a:p>
             <a:pPr lvl="2"/>
             <a:r>
-              <a:rPr lang="en-US"/>
+              <a:rPr lang="en-US" smtClean="0"/>
               <a:t>Third level</a:t>
             </a:r>
           </a:p>
           <a:p>
             <a:pPr lvl="3"/>
             <a:r>
-              <a:rPr lang="en-US"/>
+              <a:rPr lang="en-US" smtClean="0"/>
               <a:t>Fourth level</a:t>
             </a:r>
           </a:p>
           <a:p>
             <a:pPr lvl="4"/>
             <a:r>
-              <a:rPr lang="en-US"/>
+              <a:rPr lang="en-US" smtClean="0"/>
               <a:t>Fifth level</a:t>
             </a:r>
+            <a:endParaRPr lang="en-US"/>
           </a:p>
         </p:txBody>
       </p:sp>
@@ -1366,7 +1362,7 @@
           <a:p>
             <a:fld id="{5BCAD085-E8A6-8845-BD4E-CB4CCA059FC4}" type="datetimeFigureOut">
               <a:rPr lang="en-US" smtClean="0"/>
-              <a:t>5/11/2026</a:t>
+              <a:t>1/27/13</a:t>
             </a:fld>
             <a:endParaRPr lang="en-US"/>
           </a:p>
@@ -1464,9 +1460,10 @@
           </a:lstStyle>
           <a:p>
             <a:r>
-              <a:rPr lang="en-US"/>
+              <a:rPr lang="en-US" smtClean="0"/>
               <a:t>Click to edit Master title style</a:t>
             </a:r>
+            <a:endParaRPr lang="en-US"/>
           </a:p>
         </p:txBody>
       </p:sp>
@@ -1529,7 +1526,7 @@
           <a:p>
             <a:pPr lvl="0"/>
             <a:r>
-              <a:rPr lang="en-US"/>
+              <a:rPr lang="en-US" smtClean="0"/>
               <a:t>Click to edit Master text styles</a:t>
             </a:r>
           </a:p>
@@ -1585,37 +1582,38 @@
           <a:p>
             <a:pPr lvl="0"/>
             <a:r>
-              <a:rPr lang="en-US"/>
+              <a:rPr lang="en-US" smtClean="0"/>
               <a:t>Click to edit Master text styles</a:t>
             </a:r>
           </a:p>
           <a:p>
             <a:pPr lvl="1"/>
             <a:r>
-              <a:rPr lang="en-US"/>
+              <a:rPr lang="en-US" smtClean="0"/>
               <a:t>Second level</a:t>
             </a:r>
           </a:p>
           <a:p>
             <a:pPr lvl="2"/>
             <a:r>
-              <a:rPr lang="en-US"/>
+              <a:rPr lang="en-US" smtClean="0"/>
               <a:t>Third level</a:t>
             </a:r>
           </a:p>
           <a:p>
             <a:pPr lvl="3"/>
             <a:r>
-              <a:rPr lang="en-US"/>
+              <a:rPr lang="en-US" smtClean="0"/>
               <a:t>Fourth level</a:t>
             </a:r>
           </a:p>
           <a:p>
             <a:pPr lvl="4"/>
             <a:r>
-              <a:rPr lang="en-US"/>
+              <a:rPr lang="en-US" smtClean="0"/>
               <a:t>Fifth level</a:t>
             </a:r>
+            <a:endParaRPr lang="en-US"/>
           </a:p>
         </p:txBody>
       </p:sp>
@@ -1678,7 +1676,7 @@
           <a:p>
             <a:pPr lvl="0"/>
             <a:r>
-              <a:rPr lang="en-US"/>
+              <a:rPr lang="en-US" smtClean="0"/>
               <a:t>Click to edit Master text styles</a:t>
             </a:r>
           </a:p>
@@ -1734,37 +1732,38 @@
           <a:p>
             <a:pPr lvl="0"/>
             <a:r>
-              <a:rPr lang="en-US"/>
+              <a:rPr lang="en-US" smtClean="0"/>
               <a:t>Click to edit Master text styles</a:t>
             </a:r>
           </a:p>
           <a:p>
             <a:pPr lvl="1"/>
             <a:r>
-              <a:rPr lang="en-US"/>
+              <a:rPr lang="en-US" smtClean="0"/>
               <a:t>Second level</a:t>
             </a:r>
           </a:p>
           <a:p>
             <a:pPr lvl="2"/>
             <a:r>
-              <a:rPr lang="en-US"/>
+              <a:rPr lang="en-US" smtClean="0"/>
               <a:t>Third level</a:t>
             </a:r>
           </a:p>
           <a:p>
             <a:pPr lvl="3"/>
             <a:r>
-              <a:rPr lang="en-US"/>
+              <a:rPr lang="en-US" smtClean="0"/>
               <a:t>Fourth level</a:t>
             </a:r>
           </a:p>
           <a:p>
             <a:pPr lvl="4"/>
             <a:r>
-              <a:rPr lang="en-US"/>
+              <a:rPr lang="en-US" smtClean="0"/>
               <a:t>Fifth level</a:t>
             </a:r>
+            <a:endParaRPr lang="en-US"/>
           </a:p>
         </p:txBody>
       </p:sp>
@@ -1785,7 +1784,7 @@
           <a:p>
             <a:fld id="{5BCAD085-E8A6-8845-BD4E-CB4CCA059FC4}" type="datetimeFigureOut">
               <a:rPr lang="en-US" smtClean="0"/>
-              <a:t>5/11/2026</a:t>
+              <a:t>1/27/13</a:t>
             </a:fld>
             <a:endParaRPr lang="en-US"/>
           </a:p>
@@ -1879,9 +1878,10 @@
           <a:lstStyle/>
           <a:p>
             <a:r>
-              <a:rPr lang="en-US"/>
+              <a:rPr lang="en-US" smtClean="0"/>
               <a:t>Click to edit Master title style</a:t>
             </a:r>
+            <a:endParaRPr lang="en-US"/>
           </a:p>
         </p:txBody>
       </p:sp>
@@ -1902,7 +1902,7 @@
           <a:p>
             <a:fld id="{5BCAD085-E8A6-8845-BD4E-CB4CCA059FC4}" type="datetimeFigureOut">
               <a:rPr lang="en-US" smtClean="0"/>
-              <a:t>5/11/2026</a:t>
+              <a:t>1/27/13</a:t>
             </a:fld>
             <a:endParaRPr lang="en-US"/>
           </a:p>
@@ -1997,7 +1997,7 @@
           <a:p>
             <a:fld id="{5BCAD085-E8A6-8845-BD4E-CB4CCA059FC4}" type="datetimeFigureOut">
               <a:rPr lang="en-US" smtClean="0"/>
-              <a:t>5/11/2026</a:t>
+              <a:t>1/27/13</a:t>
             </a:fld>
             <a:endParaRPr lang="en-US"/>
           </a:p>
@@ -2100,9 +2100,10 @@
           </a:lstStyle>
           <a:p>
             <a:r>
-              <a:rPr lang="en-US"/>
+              <a:rPr lang="en-US" smtClean="0"/>
               <a:t>Click to edit Master title style</a:t>
             </a:r>
+            <a:endParaRPr lang="en-US"/>
           </a:p>
         </p:txBody>
       </p:sp>
@@ -2156,37 +2157,38 @@
           <a:p>
             <a:pPr lvl="0"/>
             <a:r>
-              <a:rPr lang="en-US"/>
+              <a:rPr lang="en-US" smtClean="0"/>
               <a:t>Click to edit Master text styles</a:t>
             </a:r>
           </a:p>
           <a:p>
             <a:pPr lvl="1"/>
             <a:r>
-              <a:rPr lang="en-US"/>
+              <a:rPr lang="en-US" smtClean="0"/>
               <a:t>Second level</a:t>
             </a:r>
           </a:p>
           <a:p>
             <a:pPr lvl="2"/>
             <a:r>
-              <a:rPr lang="en-US"/>
+              <a:rPr lang="en-US" smtClean="0"/>
               <a:t>Third level</a:t>
             </a:r>
           </a:p>
           <a:p>
             <a:pPr lvl="3"/>
             <a:r>
-              <a:rPr lang="en-US"/>
+              <a:rPr lang="en-US" smtClean="0"/>
               <a:t>Fourth level</a:t>
             </a:r>
           </a:p>
           <a:p>
             <a:pPr lvl="4"/>
             <a:r>
-              <a:rPr lang="en-US"/>
+              <a:rPr lang="en-US" smtClean="0"/>
               <a:t>Fifth level</a:t>
             </a:r>
+            <a:endParaRPr lang="en-US"/>
           </a:p>
         </p:txBody>
       </p:sp>
@@ -2249,7 +2251,7 @@
           <a:p>
             <a:pPr lvl="0"/>
             <a:r>
-              <a:rPr lang="en-US"/>
+              <a:rPr lang="en-US" smtClean="0"/>
               <a:t>Click to edit Master text styles</a:t>
             </a:r>
           </a:p>
@@ -2272,7 +2274,7 @@
           <a:p>
             <a:fld id="{5BCAD085-E8A6-8845-BD4E-CB4CCA059FC4}" type="datetimeFigureOut">
               <a:rPr lang="en-US" smtClean="0"/>
-              <a:t>5/11/2026</a:t>
+              <a:t>1/27/13</a:t>
             </a:fld>
             <a:endParaRPr lang="en-US"/>
           </a:p>
@@ -2375,9 +2377,10 @@
           </a:lstStyle>
           <a:p>
             <a:r>
-              <a:rPr lang="en-US"/>
+              <a:rPr lang="en-US" smtClean="0"/>
               <a:t>Click to edit Master title style</a:t>
             </a:r>
+            <a:endParaRPr lang="en-US"/>
           </a:p>
         </p:txBody>
       </p:sp>
@@ -2501,7 +2504,7 @@
           <a:p>
             <a:pPr lvl="0"/>
             <a:r>
-              <a:rPr lang="en-US"/>
+              <a:rPr lang="en-US" smtClean="0"/>
               <a:t>Click to edit Master text styles</a:t>
             </a:r>
           </a:p>
@@ -2524,7 +2527,7 @@
           <a:p>
             <a:fld id="{5BCAD085-E8A6-8845-BD4E-CB4CCA059FC4}" type="datetimeFigureOut">
               <a:rPr lang="en-US" smtClean="0"/>
-              <a:t>5/11/2026</a:t>
+              <a:t>1/27/13</a:t>
             </a:fld>
             <a:endParaRPr lang="en-US"/>
           </a:p>
@@ -2633,9 +2636,10 @@
           <a:lstStyle/>
           <a:p>
             <a:r>
-              <a:rPr lang="en-US"/>
+              <a:rPr lang="en-US" smtClean="0"/>
               <a:t>Click to edit Master title style</a:t>
             </a:r>
+            <a:endParaRPr lang="en-US"/>
           </a:p>
         </p:txBody>
       </p:sp>
@@ -2666,37 +2670,38 @@
           <a:p>
             <a:pPr lvl="0"/>
             <a:r>
-              <a:rPr lang="en-US"/>
+              <a:rPr lang="en-US" smtClean="0"/>
               <a:t>Click to edit Master text styles</a:t>
             </a:r>
           </a:p>
           <a:p>
             <a:pPr lvl="1"/>
             <a:r>
-              <a:rPr lang="en-US"/>
+              <a:rPr lang="en-US" smtClean="0"/>
               <a:t>Second level</a:t>
             </a:r>
           </a:p>
           <a:p>
             <a:pPr lvl="2"/>
             <a:r>
-              <a:rPr lang="en-US"/>
+              <a:rPr lang="en-US" smtClean="0"/>
               <a:t>Third level</a:t>
             </a:r>
           </a:p>
           <a:p>
             <a:pPr lvl="3"/>
             <a:r>
-              <a:rPr lang="en-US"/>
+              <a:rPr lang="en-US" smtClean="0"/>
               <a:t>Fourth level</a:t>
             </a:r>
           </a:p>
           <a:p>
             <a:pPr lvl="4"/>
             <a:r>
-              <a:rPr lang="en-US"/>
+              <a:rPr lang="en-US" smtClean="0"/>
               <a:t>Fifth level</a:t>
             </a:r>
+            <a:endParaRPr lang="en-US"/>
           </a:p>
         </p:txBody>
       </p:sp>
@@ -2735,7 +2740,7 @@
           <a:p>
             <a:fld id="{5BCAD085-E8A6-8845-BD4E-CB4CCA059FC4}" type="datetimeFigureOut">
               <a:rPr lang="en-US" smtClean="0"/>
-              <a:t>5/11/2026</a:t>
+              <a:t>1/27/13</a:t>
             </a:fld>
             <a:endParaRPr lang="en-US"/>
           </a:p>
@@ -3094,7 +3099,7 @@
 </file>
 
 <file path=ppt/slides/slide1.xml><?xml version="1.0" encoding="utf-8"?>
-<p:sld xmlns:a="http://schemas.openxmlformats.org/drawingml/2006/main" xmlns:r="http://schemas.openxmlformats.org/officeDocument/2006/relationships" xmlns:p="http://schemas.openxmlformats.org/presentationml/2006/main">
+<p:sld xmlns:a="http://schemas.openxmlformats.org/drawingml/2006/main" xmlns:p="http://schemas.openxmlformats.org/presentationml/2006/main" xmlns:r="http://schemas.openxmlformats.org/officeDocument/2006/relationships">
   <p:cSld>
     <p:bg>
       <p:bgPr>
@@ -3110,14 +3115,7 @@
         <p:cNvGrpSpPr/>
         <p:nvPr/>
       </p:nvGrpSpPr>
-      <p:grpSpPr>
-        <a:xfrm>
-          <a:off x="0" y="0"/>
-          <a:ext cx="0" cy="0"/>
-          <a:chOff x="0" y="0"/>
-          <a:chExt cx="0" cy="0"/>
-        </a:xfrm>
-      </p:grpSpPr>
+      <p:grpSpPr/>
       <p:sp>
         <p:nvSpPr>
           <p:cNvPr id="2" name="TextBox 1"/>
@@ -3204,8 +3202,8 @@
         </p:blipFill>
         <p:spPr>
           <a:xfrm>
-            <a:off x="658368" y="2423160"/>
-            <a:ext cx="7040880" cy="3794760"/>
+            <a:off x="805687" y="2423160"/>
+            <a:ext cx="6746240" cy="3794760"/>
           </a:xfrm>
           <a:prstGeom prst="rect">
             <a:avLst/>
@@ -3254,7 +3252,6 @@
           <a:lstStyle/>
           <a:p>
             <a:pPr algn="ctr"/>
-            <a:endParaRPr/>
           </a:p>
         </p:txBody>
       </p:sp>
@@ -3418,7 +3415,6 @@
           <a:lstStyle/>
           <a:p>
             <a:pPr algn="ctr"/>
-            <a:endParaRPr/>
           </a:p>
         </p:txBody>
       </p:sp>
@@ -3462,7 +3458,6 @@
           <a:lstStyle/>
           <a:p>
             <a:pPr algn="ctr"/>
-            <a:endParaRPr/>
           </a:p>
         </p:txBody>
       </p:sp>
@@ -3506,7 +3501,6 @@
           <a:lstStyle/>
           <a:p>
             <a:pPr algn="ctr"/>
-            <a:endParaRPr/>
           </a:p>
         </p:txBody>
       </p:sp>
@@ -3550,7 +3544,6 @@
           <a:lstStyle/>
           <a:p>
             <a:pPr algn="ctr"/>
-            <a:endParaRPr/>
           </a:p>
         </p:txBody>
       </p:sp>
@@ -3594,7 +3587,6 @@
           <a:lstStyle/>
           <a:p>
             <a:pPr algn="ctr"/>
-            <a:endParaRPr/>
           </a:p>
         </p:txBody>
       </p:sp>
@@ -3638,7 +3630,6 @@
           <a:lstStyle/>
           <a:p>
             <a:pPr algn="ctr"/>
-            <a:endParaRPr/>
           </a:p>
         </p:txBody>
       </p:sp>
@@ -3682,7 +3673,6 @@
           <a:lstStyle/>
           <a:p>
             <a:pPr algn="ctr"/>
-            <a:endParaRPr/>
           </a:p>
         </p:txBody>
       </p:sp>
@@ -3765,7 +3755,7 @@
 </file>
 
 <file path=ppt/slides/slide10.xml><?xml version="1.0" encoding="utf-8"?>
-<p:sld xmlns:a="http://schemas.openxmlformats.org/drawingml/2006/main" xmlns:r="http://schemas.openxmlformats.org/officeDocument/2006/relationships" xmlns:p="http://schemas.openxmlformats.org/presentationml/2006/main">
+<p:sld xmlns:a="http://schemas.openxmlformats.org/drawingml/2006/main" xmlns:p="http://schemas.openxmlformats.org/presentationml/2006/main" xmlns:r="http://schemas.openxmlformats.org/officeDocument/2006/relationships">
   <p:cSld>
     <p:bg>
       <p:bgPr>
@@ -3781,14 +3771,7 @@
         <p:cNvGrpSpPr/>
         <p:nvPr/>
       </p:nvGrpSpPr>
-      <p:grpSpPr>
-        <a:xfrm>
-          <a:off x="0" y="0"/>
-          <a:ext cx="0" cy="0"/>
-          <a:chOff x="0" y="0"/>
-          <a:chExt cx="0" cy="0"/>
-        </a:xfrm>
-      </p:grpSpPr>
+      <p:grpSpPr/>
       <p:sp>
         <p:nvSpPr>
           <p:cNvPr id="2" name="TextBox 1"/>
@@ -3864,7 +3847,6 @@
           <a:lstStyle/>
           <a:p>
             <a:pPr algn="ctr"/>
-            <a:endParaRPr/>
           </a:p>
         </p:txBody>
       </p:sp>
@@ -3945,7 +3927,6 @@
           <a:lstStyle/>
           <a:p>
             <a:pPr algn="ctr"/>
-            <a:endParaRPr/>
           </a:p>
         </p:txBody>
       </p:sp>
@@ -4091,7 +4072,6 @@
           <a:lstStyle/>
           <a:p>
             <a:pPr algn="ctr"/>
-            <a:endParaRPr/>
           </a:p>
         </p:txBody>
       </p:sp>
@@ -4227,7 +4207,6 @@
           <a:lstStyle/>
           <a:p>
             <a:pPr algn="ctr"/>
-            <a:endParaRPr/>
           </a:p>
         </p:txBody>
       </p:sp>
@@ -4371,7 +4350,6 @@
           <a:lstStyle/>
           <a:p>
             <a:pPr algn="ctr"/>
-            <a:endParaRPr/>
           </a:p>
         </p:txBody>
       </p:sp>
@@ -4415,7 +4393,6 @@
           <a:lstStyle/>
           <a:p>
             <a:pPr algn="ctr"/>
-            <a:endParaRPr/>
           </a:p>
         </p:txBody>
       </p:sp>
@@ -4459,7 +4436,6 @@
           <a:lstStyle/>
           <a:p>
             <a:pPr algn="ctr"/>
-            <a:endParaRPr/>
           </a:p>
         </p:txBody>
       </p:sp>
@@ -4503,7 +4479,6 @@
           <a:lstStyle/>
           <a:p>
             <a:pPr algn="ctr"/>
-            <a:endParaRPr/>
           </a:p>
         </p:txBody>
       </p:sp>
@@ -4547,7 +4522,6 @@
           <a:lstStyle/>
           <a:p>
             <a:pPr algn="ctr"/>
-            <a:endParaRPr/>
           </a:p>
         </p:txBody>
       </p:sp>
@@ -4591,7 +4565,6 @@
           <a:lstStyle/>
           <a:p>
             <a:pPr algn="ctr"/>
-            <a:endParaRPr/>
           </a:p>
         </p:txBody>
       </p:sp>
@@ -4635,7 +4608,6 @@
           <a:lstStyle/>
           <a:p>
             <a:pPr algn="ctr"/>
-            <a:endParaRPr/>
           </a:p>
         </p:txBody>
       </p:sp>
@@ -4718,7 +4690,7 @@
 </file>
 
 <file path=ppt/slides/slide11.xml><?xml version="1.0" encoding="utf-8"?>
-<p:sld xmlns:a="http://schemas.openxmlformats.org/drawingml/2006/main" xmlns:r="http://schemas.openxmlformats.org/officeDocument/2006/relationships" xmlns:p="http://schemas.openxmlformats.org/presentationml/2006/main">
+<p:sld xmlns:a="http://schemas.openxmlformats.org/drawingml/2006/main" xmlns:p="http://schemas.openxmlformats.org/presentationml/2006/main" xmlns:r="http://schemas.openxmlformats.org/officeDocument/2006/relationships">
   <p:cSld>
     <p:bg>
       <p:bgPr>
@@ -4734,14 +4706,7 @@
         <p:cNvGrpSpPr/>
         <p:nvPr/>
       </p:nvGrpSpPr>
-      <p:grpSpPr>
-        <a:xfrm>
-          <a:off x="0" y="0"/>
-          <a:ext cx="0" cy="0"/>
-          <a:chOff x="0" y="0"/>
-          <a:chExt cx="0" cy="0"/>
-        </a:xfrm>
-      </p:grpSpPr>
+      <p:grpSpPr/>
       <p:sp>
         <p:nvSpPr>
           <p:cNvPr id="2" name="TextBox 1"/>
@@ -4817,7 +4782,6 @@
           <a:lstStyle/>
           <a:p>
             <a:pPr algn="ctr"/>
-            <a:endParaRPr/>
           </a:p>
         </p:txBody>
       </p:sp>
@@ -4872,8 +4836,8 @@
         </p:blipFill>
         <p:spPr>
           <a:xfrm>
-            <a:off x="685800" y="1325880"/>
-            <a:ext cx="5486400" cy="3090672"/>
+            <a:off x="685800" y="1328166"/>
+            <a:ext cx="5486400" cy="3086100"/>
           </a:xfrm>
           <a:prstGeom prst="rect">
             <a:avLst/>
@@ -4922,7 +4886,6 @@
           <a:lstStyle/>
           <a:p>
             <a:pPr algn="ctr"/>
-            <a:endParaRPr/>
           </a:p>
         </p:txBody>
       </p:sp>
@@ -5058,7 +5021,6 @@
           <a:lstStyle/>
           <a:p>
             <a:pPr algn="ctr"/>
-            <a:endParaRPr/>
           </a:p>
         </p:txBody>
       </p:sp>
@@ -5194,7 +5156,6 @@
           <a:lstStyle/>
           <a:p>
             <a:pPr algn="ctr"/>
-            <a:endParaRPr/>
           </a:p>
         </p:txBody>
       </p:sp>
@@ -5328,7 +5289,6 @@
           <a:lstStyle/>
           <a:p>
             <a:pPr algn="ctr"/>
-            <a:endParaRPr/>
           </a:p>
         </p:txBody>
       </p:sp>
@@ -5372,7 +5332,6 @@
           <a:lstStyle/>
           <a:p>
             <a:pPr algn="ctr"/>
-            <a:endParaRPr/>
           </a:p>
         </p:txBody>
       </p:sp>
@@ -5416,7 +5375,6 @@
           <a:lstStyle/>
           <a:p>
             <a:pPr algn="ctr"/>
-            <a:endParaRPr/>
           </a:p>
         </p:txBody>
       </p:sp>
@@ -5460,7 +5418,6 @@
           <a:lstStyle/>
           <a:p>
             <a:pPr algn="ctr"/>
-            <a:endParaRPr/>
           </a:p>
         </p:txBody>
       </p:sp>
@@ -5504,7 +5461,6 @@
           <a:lstStyle/>
           <a:p>
             <a:pPr algn="ctr"/>
-            <a:endParaRPr/>
           </a:p>
         </p:txBody>
       </p:sp>
@@ -5548,7 +5504,6 @@
           <a:lstStyle/>
           <a:p>
             <a:pPr algn="ctr"/>
-            <a:endParaRPr/>
           </a:p>
         </p:txBody>
       </p:sp>
@@ -5592,7 +5547,6 @@
           <a:lstStyle/>
           <a:p>
             <a:pPr algn="ctr"/>
-            <a:endParaRPr/>
           </a:p>
         </p:txBody>
       </p:sp>
@@ -5675,7 +5629,7 @@
 </file>
 
 <file path=ppt/slides/slide12.xml><?xml version="1.0" encoding="utf-8"?>
-<p:sld xmlns:a="http://schemas.openxmlformats.org/drawingml/2006/main" xmlns:r="http://schemas.openxmlformats.org/officeDocument/2006/relationships" xmlns:p="http://schemas.openxmlformats.org/presentationml/2006/main">
+<p:sld xmlns:a="http://schemas.openxmlformats.org/drawingml/2006/main" xmlns:p="http://schemas.openxmlformats.org/presentationml/2006/main" xmlns:r="http://schemas.openxmlformats.org/officeDocument/2006/relationships">
   <p:cSld>
     <p:bg>
       <p:bgPr>
@@ -5691,14 +5645,7 @@
         <p:cNvGrpSpPr/>
         <p:nvPr/>
       </p:nvGrpSpPr>
-      <p:grpSpPr>
-        <a:xfrm>
-          <a:off x="0" y="0"/>
-          <a:ext cx="0" cy="0"/>
-          <a:chOff x="0" y="0"/>
-          <a:chExt cx="0" cy="0"/>
-        </a:xfrm>
-      </p:grpSpPr>
+      <p:grpSpPr/>
       <p:sp>
         <p:nvSpPr>
           <p:cNvPr id="2" name="TextBox 1"/>
@@ -5774,7 +5721,6 @@
           <a:lstStyle/>
           <a:p>
             <a:pPr algn="ctr"/>
-            <a:endParaRPr/>
           </a:p>
         </p:txBody>
       </p:sp>
@@ -5855,7 +5801,6 @@
           <a:lstStyle/>
           <a:p>
             <a:pPr algn="ctr"/>
-            <a:endParaRPr/>
           </a:p>
         </p:txBody>
       </p:sp>
@@ -6001,7 +5946,6 @@
           <a:lstStyle/>
           <a:p>
             <a:pPr algn="ctr"/>
-            <a:endParaRPr/>
           </a:p>
         </p:txBody>
       </p:sp>
@@ -6185,7 +6129,6 @@
           <a:lstStyle/>
           <a:p>
             <a:pPr algn="ctr"/>
-            <a:endParaRPr/>
           </a:p>
         </p:txBody>
       </p:sp>
@@ -6229,7 +6172,6 @@
           <a:lstStyle/>
           <a:p>
             <a:pPr algn="ctr"/>
-            <a:endParaRPr/>
           </a:p>
         </p:txBody>
       </p:sp>
@@ -6273,7 +6215,6 @@
           <a:lstStyle/>
           <a:p>
             <a:pPr algn="ctr"/>
-            <a:endParaRPr/>
           </a:p>
         </p:txBody>
       </p:sp>
@@ -6317,7 +6258,6 @@
           <a:lstStyle/>
           <a:p>
             <a:pPr algn="ctr"/>
-            <a:endParaRPr/>
           </a:p>
         </p:txBody>
       </p:sp>
@@ -6361,7 +6301,6 @@
           <a:lstStyle/>
           <a:p>
             <a:pPr algn="ctr"/>
-            <a:endParaRPr/>
           </a:p>
         </p:txBody>
       </p:sp>
@@ -6405,7 +6344,6 @@
           <a:lstStyle/>
           <a:p>
             <a:pPr algn="ctr"/>
-            <a:endParaRPr/>
           </a:p>
         </p:txBody>
       </p:sp>
@@ -6449,7 +6387,6 @@
           <a:lstStyle/>
           <a:p>
             <a:pPr algn="ctr"/>
-            <a:endParaRPr/>
           </a:p>
         </p:txBody>
       </p:sp>
@@ -6532,7 +6469,7 @@
 </file>
 
 <file path=ppt/slides/slide13.xml><?xml version="1.0" encoding="utf-8"?>
-<p:sld xmlns:a="http://schemas.openxmlformats.org/drawingml/2006/main" xmlns:r="http://schemas.openxmlformats.org/officeDocument/2006/relationships" xmlns:p="http://schemas.openxmlformats.org/presentationml/2006/main">
+<p:sld xmlns:a="http://schemas.openxmlformats.org/drawingml/2006/main" xmlns:p="http://schemas.openxmlformats.org/presentationml/2006/main" xmlns:r="http://schemas.openxmlformats.org/officeDocument/2006/relationships">
   <p:cSld>
     <p:bg>
       <p:bgPr>
@@ -6548,14 +6485,7 @@
         <p:cNvGrpSpPr/>
         <p:nvPr/>
       </p:nvGrpSpPr>
-      <p:grpSpPr>
-        <a:xfrm>
-          <a:off x="0" y="0"/>
-          <a:ext cx="0" cy="0"/>
-          <a:chOff x="0" y="0"/>
-          <a:chExt cx="0" cy="0"/>
-        </a:xfrm>
-      </p:grpSpPr>
+      <p:grpSpPr/>
       <p:sp>
         <p:nvSpPr>
           <p:cNvPr id="2" name="TextBox 1"/>
@@ -6631,7 +6561,6 @@
           <a:lstStyle/>
           <a:p>
             <a:pPr algn="ctr"/>
-            <a:endParaRPr/>
           </a:p>
         </p:txBody>
       </p:sp>
@@ -6689,34 +6618,10 @@
                 <a:tableStyleId>{5C22544A-7EE6-4342-B048-85BDC9FD1C3A}</a:tableStyleId>
               </a:tblPr>
               <a:tblGrid>
-                <a:gridCol w="731520">
-                  <a:extLst>
-                    <a:ext uri="{9D8B030D-6E8A-4147-A177-3AD203B41FA5}">
-                      <a16:colId xmlns:a16="http://schemas.microsoft.com/office/drawing/2014/main" val="20000"/>
-                    </a:ext>
-                  </a:extLst>
-                </a:gridCol>
-                <a:gridCol w="2194560">
-                  <a:extLst>
-                    <a:ext uri="{9D8B030D-6E8A-4147-A177-3AD203B41FA5}">
-                      <a16:colId xmlns:a16="http://schemas.microsoft.com/office/drawing/2014/main" val="20001"/>
-                    </a:ext>
-                  </a:extLst>
-                </a:gridCol>
-                <a:gridCol w="4663440">
-                  <a:extLst>
-                    <a:ext uri="{9D8B030D-6E8A-4147-A177-3AD203B41FA5}">
-                      <a16:colId xmlns:a16="http://schemas.microsoft.com/office/drawing/2014/main" val="20002"/>
-                    </a:ext>
-                  </a:extLst>
-                </a:gridCol>
-                <a:gridCol w="3246120">
-                  <a:extLst>
-                    <a:ext uri="{9D8B030D-6E8A-4147-A177-3AD203B41FA5}">
-                      <a16:colId xmlns:a16="http://schemas.microsoft.com/office/drawing/2014/main" val="20003"/>
-                    </a:ext>
-                  </a:extLst>
-                </a:gridCol>
+                <a:gridCol w="731520"/>
+                <a:gridCol w="2194560"/>
+                <a:gridCol w="4663440"/>
+                <a:gridCol w="3246120"/>
               </a:tblGrid>
               <a:tr h="708660">
                 <a:tc>
@@ -6807,11 +6712,6 @@
                     </a:solidFill>
                   </a:tcPr>
                 </a:tc>
-                <a:extLst>
-                  <a:ext uri="{0D108BD9-81ED-4DB2-BD59-A6C34878D82A}">
-                    <a16:rowId xmlns:a16="http://schemas.microsoft.com/office/drawing/2014/main" val="10000"/>
-                  </a:ext>
-                </a:extLst>
               </a:tr>
               <a:tr h="708660">
                 <a:tc>
@@ -6902,11 +6802,6 @@
                     </a:solidFill>
                   </a:tcPr>
                 </a:tc>
-                <a:extLst>
-                  <a:ext uri="{0D108BD9-81ED-4DB2-BD59-A6C34878D82A}">
-                    <a16:rowId xmlns:a16="http://schemas.microsoft.com/office/drawing/2014/main" val="10001"/>
-                  </a:ext>
-                </a:extLst>
               </a:tr>
               <a:tr h="708660">
                 <a:tc>
@@ -6997,11 +6892,6 @@
                     </a:solidFill>
                   </a:tcPr>
                 </a:tc>
-                <a:extLst>
-                  <a:ext uri="{0D108BD9-81ED-4DB2-BD59-A6C34878D82A}">
-                    <a16:rowId xmlns:a16="http://schemas.microsoft.com/office/drawing/2014/main" val="10002"/>
-                  </a:ext>
-                </a:extLst>
               </a:tr>
               <a:tr h="708660">
                 <a:tc>
@@ -7092,11 +6982,6 @@
                     </a:solidFill>
                   </a:tcPr>
                 </a:tc>
-                <a:extLst>
-                  <a:ext uri="{0D108BD9-81ED-4DB2-BD59-A6C34878D82A}">
-                    <a16:rowId xmlns:a16="http://schemas.microsoft.com/office/drawing/2014/main" val="10003"/>
-                  </a:ext>
-                </a:extLst>
               </a:tr>
               <a:tr h="708660">
                 <a:tc>
@@ -7187,11 +7072,6 @@
                     </a:solidFill>
                   </a:tcPr>
                 </a:tc>
-                <a:extLst>
-                  <a:ext uri="{0D108BD9-81ED-4DB2-BD59-A6C34878D82A}">
-                    <a16:rowId xmlns:a16="http://schemas.microsoft.com/office/drawing/2014/main" val="10004"/>
-                  </a:ext>
-                </a:extLst>
               </a:tr>
               <a:tr h="708660">
                 <a:tc>
@@ -7282,11 +7162,6 @@
                     </a:solidFill>
                   </a:tcPr>
                 </a:tc>
-                <a:extLst>
-                  <a:ext uri="{0D108BD9-81ED-4DB2-BD59-A6C34878D82A}">
-                    <a16:rowId xmlns:a16="http://schemas.microsoft.com/office/drawing/2014/main" val="10005"/>
-                  </a:ext>
-                </a:extLst>
               </a:tr>
             </a:tbl>
           </a:graphicData>
@@ -7332,7 +7207,6 @@
           <a:lstStyle/>
           <a:p>
             <a:pPr algn="ctr"/>
-            <a:endParaRPr/>
           </a:p>
         </p:txBody>
       </p:sp>
@@ -7376,7 +7250,6 @@
           <a:lstStyle/>
           <a:p>
             <a:pPr algn="ctr"/>
-            <a:endParaRPr/>
           </a:p>
         </p:txBody>
       </p:sp>
@@ -7420,7 +7293,6 @@
           <a:lstStyle/>
           <a:p>
             <a:pPr algn="ctr"/>
-            <a:endParaRPr/>
           </a:p>
         </p:txBody>
       </p:sp>
@@ -7464,7 +7336,6 @@
           <a:lstStyle/>
           <a:p>
             <a:pPr algn="ctr"/>
-            <a:endParaRPr/>
           </a:p>
         </p:txBody>
       </p:sp>
@@ -7508,7 +7379,6 @@
           <a:lstStyle/>
           <a:p>
             <a:pPr algn="ctr"/>
-            <a:endParaRPr/>
           </a:p>
         </p:txBody>
       </p:sp>
@@ -7552,7 +7422,6 @@
           <a:lstStyle/>
           <a:p>
             <a:pPr algn="ctr"/>
-            <a:endParaRPr/>
           </a:p>
         </p:txBody>
       </p:sp>
@@ -7596,7 +7465,6 @@
           <a:lstStyle/>
           <a:p>
             <a:pPr algn="ctr"/>
-            <a:endParaRPr/>
           </a:p>
         </p:txBody>
       </p:sp>
@@ -7679,7 +7547,7 @@
 </file>
 
 <file path=ppt/slides/slide14.xml><?xml version="1.0" encoding="utf-8"?>
-<p:sld xmlns:a="http://schemas.openxmlformats.org/drawingml/2006/main" xmlns:r="http://schemas.openxmlformats.org/officeDocument/2006/relationships" xmlns:p="http://schemas.openxmlformats.org/presentationml/2006/main">
+<p:sld xmlns:a="http://schemas.openxmlformats.org/drawingml/2006/main" xmlns:p="http://schemas.openxmlformats.org/presentationml/2006/main" xmlns:r="http://schemas.openxmlformats.org/officeDocument/2006/relationships">
   <p:cSld>
     <p:bg>
       <p:bgPr>
@@ -7695,14 +7563,7 @@
         <p:cNvGrpSpPr/>
         <p:nvPr/>
       </p:nvGrpSpPr>
-      <p:grpSpPr>
-        <a:xfrm>
-          <a:off x="0" y="0"/>
-          <a:ext cx="0" cy="0"/>
-          <a:chOff x="0" y="0"/>
-          <a:chExt cx="0" cy="0"/>
-        </a:xfrm>
-      </p:grpSpPr>
+      <p:grpSpPr/>
       <p:sp>
         <p:nvSpPr>
           <p:cNvPr id="2" name="TextBox 1"/>
@@ -7778,7 +7639,6 @@
           <a:lstStyle/>
           <a:p>
             <a:pPr algn="ctr"/>
-            <a:endParaRPr/>
           </a:p>
         </p:txBody>
       </p:sp>
@@ -7883,7 +7743,6 @@
           <a:lstStyle/>
           <a:p>
             <a:pPr algn="ctr"/>
-            <a:endParaRPr/>
           </a:p>
         </p:txBody>
       </p:sp>
@@ -8019,7 +7878,6 @@
           <a:lstStyle/>
           <a:p>
             <a:pPr algn="ctr"/>
-            <a:endParaRPr/>
           </a:p>
         </p:txBody>
       </p:sp>
@@ -8153,7 +8011,6 @@
           <a:lstStyle/>
           <a:p>
             <a:pPr algn="ctr"/>
-            <a:endParaRPr/>
           </a:p>
         </p:txBody>
       </p:sp>
@@ -8197,7 +8054,6 @@
           <a:lstStyle/>
           <a:p>
             <a:pPr algn="ctr"/>
-            <a:endParaRPr/>
           </a:p>
         </p:txBody>
       </p:sp>
@@ -8241,7 +8097,6 @@
           <a:lstStyle/>
           <a:p>
             <a:pPr algn="ctr"/>
-            <a:endParaRPr/>
           </a:p>
         </p:txBody>
       </p:sp>
@@ -8285,7 +8140,6 @@
           <a:lstStyle/>
           <a:p>
             <a:pPr algn="ctr"/>
-            <a:endParaRPr/>
           </a:p>
         </p:txBody>
       </p:sp>
@@ -8329,7 +8183,6 @@
           <a:lstStyle/>
           <a:p>
             <a:pPr algn="ctr"/>
-            <a:endParaRPr/>
           </a:p>
         </p:txBody>
       </p:sp>
@@ -8373,7 +8226,6 @@
           <a:lstStyle/>
           <a:p>
             <a:pPr algn="ctr"/>
-            <a:endParaRPr/>
           </a:p>
         </p:txBody>
       </p:sp>
@@ -8417,7 +8269,6 @@
           <a:lstStyle/>
           <a:p>
             <a:pPr algn="ctr"/>
-            <a:endParaRPr/>
           </a:p>
         </p:txBody>
       </p:sp>
@@ -8500,7 +8351,7 @@
 </file>
 
 <file path=ppt/slides/slide15.xml><?xml version="1.0" encoding="utf-8"?>
-<p:sld xmlns:a="http://schemas.openxmlformats.org/drawingml/2006/main" xmlns:r="http://schemas.openxmlformats.org/officeDocument/2006/relationships" xmlns:p="http://schemas.openxmlformats.org/presentationml/2006/main">
+<p:sld xmlns:a="http://schemas.openxmlformats.org/drawingml/2006/main" xmlns:p="http://schemas.openxmlformats.org/presentationml/2006/main" xmlns:r="http://schemas.openxmlformats.org/officeDocument/2006/relationships">
   <p:cSld>
     <p:bg>
       <p:bgPr>
@@ -8516,14 +8367,7 @@
         <p:cNvGrpSpPr/>
         <p:nvPr/>
       </p:nvGrpSpPr>
-      <p:grpSpPr>
-        <a:xfrm>
-          <a:off x="0" y="0"/>
-          <a:ext cx="0" cy="0"/>
-          <a:chOff x="0" y="0"/>
-          <a:chExt cx="0" cy="0"/>
-        </a:xfrm>
-      </p:grpSpPr>
+      <p:grpSpPr/>
       <p:sp>
         <p:nvSpPr>
           <p:cNvPr id="2" name="TextBox 1"/>
@@ -8599,7 +8443,6 @@
           <a:lstStyle/>
           <a:p>
             <a:pPr algn="ctr"/>
-            <a:endParaRPr/>
           </a:p>
         </p:txBody>
       </p:sp>
@@ -8657,27 +8500,9 @@
                 <a:tableStyleId>{5C22544A-7EE6-4342-B048-85BDC9FD1C3A}</a:tableStyleId>
               </a:tblPr>
               <a:tblGrid>
-                <a:gridCol w="1097280">
-                  <a:extLst>
-                    <a:ext uri="{9D8B030D-6E8A-4147-A177-3AD203B41FA5}">
-                      <a16:colId xmlns:a16="http://schemas.microsoft.com/office/drawing/2014/main" val="20000"/>
-                    </a:ext>
-                  </a:extLst>
-                </a:gridCol>
-                <a:gridCol w="3291840">
-                  <a:extLst>
-                    <a:ext uri="{9D8B030D-6E8A-4147-A177-3AD203B41FA5}">
-                      <a16:colId xmlns:a16="http://schemas.microsoft.com/office/drawing/2014/main" val="20001"/>
-                    </a:ext>
-                  </a:extLst>
-                </a:gridCol>
-                <a:gridCol w="6309360">
-                  <a:extLst>
-                    <a:ext uri="{9D8B030D-6E8A-4147-A177-3AD203B41FA5}">
-                      <a16:colId xmlns:a16="http://schemas.microsoft.com/office/drawing/2014/main" val="20002"/>
-                    </a:ext>
-                  </a:extLst>
-                </a:gridCol>
+                <a:gridCol w="1097280"/>
+                <a:gridCol w="3291840"/>
+                <a:gridCol w="6309360"/>
               </a:tblGrid>
               <a:tr h="672737">
                 <a:tc>
@@ -8746,11 +8571,6 @@
                     </a:solidFill>
                   </a:tcPr>
                 </a:tc>
-                <a:extLst>
-                  <a:ext uri="{0D108BD9-81ED-4DB2-BD59-A6C34878D82A}">
-                    <a16:rowId xmlns:a16="http://schemas.microsoft.com/office/drawing/2014/main" val="10000"/>
-                  </a:ext>
-                </a:extLst>
               </a:tr>
               <a:tr h="672737">
                 <a:tc>
@@ -8819,11 +8639,6 @@
                     </a:solidFill>
                   </a:tcPr>
                 </a:tc>
-                <a:extLst>
-                  <a:ext uri="{0D108BD9-81ED-4DB2-BD59-A6C34878D82A}">
-                    <a16:rowId xmlns:a16="http://schemas.microsoft.com/office/drawing/2014/main" val="10001"/>
-                  </a:ext>
-                </a:extLst>
               </a:tr>
               <a:tr h="672737">
                 <a:tc>
@@ -8892,11 +8707,6 @@
                     </a:solidFill>
                   </a:tcPr>
                 </a:tc>
-                <a:extLst>
-                  <a:ext uri="{0D108BD9-81ED-4DB2-BD59-A6C34878D82A}">
-                    <a16:rowId xmlns:a16="http://schemas.microsoft.com/office/drawing/2014/main" val="10002"/>
-                  </a:ext>
-                </a:extLst>
               </a:tr>
               <a:tr h="672737">
                 <a:tc>
@@ -8965,11 +8775,6 @@
                     </a:solidFill>
                   </a:tcPr>
                 </a:tc>
-                <a:extLst>
-                  <a:ext uri="{0D108BD9-81ED-4DB2-BD59-A6C34878D82A}">
-                    <a16:rowId xmlns:a16="http://schemas.microsoft.com/office/drawing/2014/main" val="10003"/>
-                  </a:ext>
-                </a:extLst>
               </a:tr>
               <a:tr h="672737">
                 <a:tc>
@@ -9038,11 +8843,6 @@
                     </a:solidFill>
                   </a:tcPr>
                 </a:tc>
-                <a:extLst>
-                  <a:ext uri="{0D108BD9-81ED-4DB2-BD59-A6C34878D82A}">
-                    <a16:rowId xmlns:a16="http://schemas.microsoft.com/office/drawing/2014/main" val="10004"/>
-                  </a:ext>
-                </a:extLst>
               </a:tr>
               <a:tr h="672737">
                 <a:tc>
@@ -9111,11 +8911,6 @@
                     </a:solidFill>
                   </a:tcPr>
                 </a:tc>
-                <a:extLst>
-                  <a:ext uri="{0D108BD9-81ED-4DB2-BD59-A6C34878D82A}">
-                    <a16:rowId xmlns:a16="http://schemas.microsoft.com/office/drawing/2014/main" val="10005"/>
-                  </a:ext>
-                </a:extLst>
               </a:tr>
               <a:tr h="672738">
                 <a:tc>
@@ -9184,11 +8979,6 @@
                     </a:solidFill>
                   </a:tcPr>
                 </a:tc>
-                <a:extLst>
-                  <a:ext uri="{0D108BD9-81ED-4DB2-BD59-A6C34878D82A}">
-                    <a16:rowId xmlns:a16="http://schemas.microsoft.com/office/drawing/2014/main" val="10006"/>
-                  </a:ext>
-                </a:extLst>
               </a:tr>
             </a:tbl>
           </a:graphicData>
@@ -9234,7 +9024,6 @@
           <a:lstStyle/>
           <a:p>
             <a:pPr algn="ctr"/>
-            <a:endParaRPr/>
           </a:p>
         </p:txBody>
       </p:sp>
@@ -9278,7 +9067,6 @@
           <a:lstStyle/>
           <a:p>
             <a:pPr algn="ctr"/>
-            <a:endParaRPr/>
           </a:p>
         </p:txBody>
       </p:sp>
@@ -9322,7 +9110,6 @@
           <a:lstStyle/>
           <a:p>
             <a:pPr algn="ctr"/>
-            <a:endParaRPr/>
           </a:p>
         </p:txBody>
       </p:sp>
@@ -9366,7 +9153,6 @@
           <a:lstStyle/>
           <a:p>
             <a:pPr algn="ctr"/>
-            <a:endParaRPr/>
           </a:p>
         </p:txBody>
       </p:sp>
@@ -9410,7 +9196,6 @@
           <a:lstStyle/>
           <a:p>
             <a:pPr algn="ctr"/>
-            <a:endParaRPr/>
           </a:p>
         </p:txBody>
       </p:sp>
@@ -9454,7 +9239,6 @@
           <a:lstStyle/>
           <a:p>
             <a:pPr algn="ctr"/>
-            <a:endParaRPr/>
           </a:p>
         </p:txBody>
       </p:sp>
@@ -9498,7 +9282,6 @@
           <a:lstStyle/>
           <a:p>
             <a:pPr algn="ctr"/>
-            <a:endParaRPr/>
           </a:p>
         </p:txBody>
       </p:sp>
@@ -9581,7 +9364,7 @@
 </file>
 
 <file path=ppt/slides/slide16.xml><?xml version="1.0" encoding="utf-8"?>
-<p:sld xmlns:a="http://schemas.openxmlformats.org/drawingml/2006/main" xmlns:r="http://schemas.openxmlformats.org/officeDocument/2006/relationships" xmlns:p="http://schemas.openxmlformats.org/presentationml/2006/main">
+<p:sld xmlns:a="http://schemas.openxmlformats.org/drawingml/2006/main" xmlns:p="http://schemas.openxmlformats.org/presentationml/2006/main" xmlns:r="http://schemas.openxmlformats.org/officeDocument/2006/relationships">
   <p:cSld>
     <p:bg>
       <p:bgPr>
@@ -9597,14 +9380,7 @@
         <p:cNvGrpSpPr/>
         <p:nvPr/>
       </p:nvGrpSpPr>
-      <p:grpSpPr>
-        <a:xfrm>
-          <a:off x="0" y="0"/>
-          <a:ext cx="0" cy="0"/>
-          <a:chOff x="0" y="0"/>
-          <a:chExt cx="0" cy="0"/>
-        </a:xfrm>
-      </p:grpSpPr>
+      <p:grpSpPr/>
       <p:sp>
         <p:nvSpPr>
           <p:cNvPr id="2" name="TextBox 1"/>
@@ -9680,7 +9456,6 @@
           <a:lstStyle/>
           <a:p>
             <a:pPr algn="ctr"/>
-            <a:endParaRPr/>
           </a:p>
         </p:txBody>
       </p:sp>
@@ -9761,7 +9536,6 @@
           <a:lstStyle/>
           <a:p>
             <a:pPr algn="ctr"/>
-            <a:endParaRPr/>
           </a:p>
         </p:txBody>
       </p:sp>
@@ -9917,7 +9691,6 @@
           <a:lstStyle/>
           <a:p>
             <a:pPr algn="ctr"/>
-            <a:endParaRPr/>
           </a:p>
         </p:txBody>
       </p:sp>
@@ -10071,7 +9844,6 @@
           <a:lstStyle/>
           <a:p>
             <a:pPr algn="ctr"/>
-            <a:endParaRPr/>
           </a:p>
         </p:txBody>
       </p:sp>
@@ -10115,7 +9887,6 @@
           <a:lstStyle/>
           <a:p>
             <a:pPr algn="ctr"/>
-            <a:endParaRPr/>
           </a:p>
         </p:txBody>
       </p:sp>
@@ -10159,7 +9930,6 @@
           <a:lstStyle/>
           <a:p>
             <a:pPr algn="ctr"/>
-            <a:endParaRPr/>
           </a:p>
         </p:txBody>
       </p:sp>
@@ -10203,7 +9973,6 @@
           <a:lstStyle/>
           <a:p>
             <a:pPr algn="ctr"/>
-            <a:endParaRPr/>
           </a:p>
         </p:txBody>
       </p:sp>
@@ -10247,7 +10016,6 @@
           <a:lstStyle/>
           <a:p>
             <a:pPr algn="ctr"/>
-            <a:endParaRPr/>
           </a:p>
         </p:txBody>
       </p:sp>
@@ -10291,7 +10059,6 @@
           <a:lstStyle/>
           <a:p>
             <a:pPr algn="ctr"/>
-            <a:endParaRPr/>
           </a:p>
         </p:txBody>
       </p:sp>
@@ -10335,7 +10102,6 @@
           <a:lstStyle/>
           <a:p>
             <a:pPr algn="ctr"/>
-            <a:endParaRPr/>
           </a:p>
         </p:txBody>
       </p:sp>
@@ -10418,7 +10184,7 @@
 </file>
 
 <file path=ppt/slides/slide17.xml><?xml version="1.0" encoding="utf-8"?>
-<p:sld xmlns:a="http://schemas.openxmlformats.org/drawingml/2006/main" xmlns:r="http://schemas.openxmlformats.org/officeDocument/2006/relationships" xmlns:p="http://schemas.openxmlformats.org/presentationml/2006/main">
+<p:sld xmlns:a="http://schemas.openxmlformats.org/drawingml/2006/main" xmlns:p="http://schemas.openxmlformats.org/presentationml/2006/main" xmlns:r="http://schemas.openxmlformats.org/officeDocument/2006/relationships">
   <p:cSld>
     <p:bg>
       <p:bgPr>
@@ -10434,14 +10200,7 @@
         <p:cNvGrpSpPr/>
         <p:nvPr/>
       </p:nvGrpSpPr>
-      <p:grpSpPr>
-        <a:xfrm>
-          <a:off x="0" y="0"/>
-          <a:ext cx="0" cy="0"/>
-          <a:chOff x="0" y="0"/>
-          <a:chExt cx="0" cy="0"/>
-        </a:xfrm>
-      </p:grpSpPr>
+      <p:grpSpPr/>
       <p:sp>
         <p:nvSpPr>
           <p:cNvPr id="2" name="TextBox 1"/>
@@ -10517,7 +10276,6 @@
           <a:lstStyle/>
           <a:p>
             <a:pPr algn="ctr"/>
-            <a:endParaRPr/>
           </a:p>
         </p:txBody>
       </p:sp>
@@ -10575,20 +10333,8 @@
                 <a:tableStyleId>{5C22544A-7EE6-4342-B048-85BDC9FD1C3A}</a:tableStyleId>
               </a:tblPr>
               <a:tblGrid>
-                <a:gridCol w="2103120">
-                  <a:extLst>
-                    <a:ext uri="{9D8B030D-6E8A-4147-A177-3AD203B41FA5}">
-                      <a16:colId xmlns:a16="http://schemas.microsoft.com/office/drawing/2014/main" val="20000"/>
-                    </a:ext>
-                  </a:extLst>
-                </a:gridCol>
-                <a:gridCol w="8686800">
-                  <a:extLst>
-                    <a:ext uri="{9D8B030D-6E8A-4147-A177-3AD203B41FA5}">
-                      <a16:colId xmlns:a16="http://schemas.microsoft.com/office/drawing/2014/main" val="20001"/>
-                    </a:ext>
-                  </a:extLst>
-                </a:gridCol>
+                <a:gridCol w="2103120"/>
+                <a:gridCol w="8686800"/>
               </a:tblGrid>
               <a:tr h="754380">
                 <a:tc>
@@ -10635,11 +10381,6 @@
                     </a:solidFill>
                   </a:tcPr>
                 </a:tc>
-                <a:extLst>
-                  <a:ext uri="{0D108BD9-81ED-4DB2-BD59-A6C34878D82A}">
-                    <a16:rowId xmlns:a16="http://schemas.microsoft.com/office/drawing/2014/main" val="10000"/>
-                  </a:ext>
-                </a:extLst>
               </a:tr>
               <a:tr h="754380">
                 <a:tc>
@@ -10686,11 +10427,6 @@
                     </a:solidFill>
                   </a:tcPr>
                 </a:tc>
-                <a:extLst>
-                  <a:ext uri="{0D108BD9-81ED-4DB2-BD59-A6C34878D82A}">
-                    <a16:rowId xmlns:a16="http://schemas.microsoft.com/office/drawing/2014/main" val="10001"/>
-                  </a:ext>
-                </a:extLst>
               </a:tr>
               <a:tr h="754380">
                 <a:tc>
@@ -10737,11 +10473,6 @@
                     </a:solidFill>
                   </a:tcPr>
                 </a:tc>
-                <a:extLst>
-                  <a:ext uri="{0D108BD9-81ED-4DB2-BD59-A6C34878D82A}">
-                    <a16:rowId xmlns:a16="http://schemas.microsoft.com/office/drawing/2014/main" val="10002"/>
-                  </a:ext>
-                </a:extLst>
               </a:tr>
               <a:tr h="754380">
                 <a:tc>
@@ -10788,11 +10519,6 @@
                     </a:solidFill>
                   </a:tcPr>
                 </a:tc>
-                <a:extLst>
-                  <a:ext uri="{0D108BD9-81ED-4DB2-BD59-A6C34878D82A}">
-                    <a16:rowId xmlns:a16="http://schemas.microsoft.com/office/drawing/2014/main" val="10003"/>
-                  </a:ext>
-                </a:extLst>
               </a:tr>
               <a:tr h="754380">
                 <a:tc>
@@ -10839,11 +10565,6 @@
                     </a:solidFill>
                   </a:tcPr>
                 </a:tc>
-                <a:extLst>
-                  <a:ext uri="{0D108BD9-81ED-4DB2-BD59-A6C34878D82A}">
-                    <a16:rowId xmlns:a16="http://schemas.microsoft.com/office/drawing/2014/main" val="10004"/>
-                  </a:ext>
-                </a:extLst>
               </a:tr>
               <a:tr h="754380">
                 <a:tc>
@@ -10890,11 +10611,6 @@
                     </a:solidFill>
                   </a:tcPr>
                 </a:tc>
-                <a:extLst>
-                  <a:ext uri="{0D108BD9-81ED-4DB2-BD59-A6C34878D82A}">
-                    <a16:rowId xmlns:a16="http://schemas.microsoft.com/office/drawing/2014/main" val="10005"/>
-                  </a:ext>
-                </a:extLst>
               </a:tr>
             </a:tbl>
           </a:graphicData>
@@ -10940,7 +10656,6 @@
           <a:lstStyle/>
           <a:p>
             <a:pPr algn="ctr"/>
-            <a:endParaRPr/>
           </a:p>
         </p:txBody>
       </p:sp>
@@ -10984,7 +10699,6 @@
           <a:lstStyle/>
           <a:p>
             <a:pPr algn="ctr"/>
-            <a:endParaRPr/>
           </a:p>
         </p:txBody>
       </p:sp>
@@ -11028,7 +10742,6 @@
           <a:lstStyle/>
           <a:p>
             <a:pPr algn="ctr"/>
-            <a:endParaRPr/>
           </a:p>
         </p:txBody>
       </p:sp>
@@ -11072,7 +10785,6 @@
           <a:lstStyle/>
           <a:p>
             <a:pPr algn="ctr"/>
-            <a:endParaRPr/>
           </a:p>
         </p:txBody>
       </p:sp>
@@ -11116,7 +10828,6 @@
           <a:lstStyle/>
           <a:p>
             <a:pPr algn="ctr"/>
-            <a:endParaRPr/>
           </a:p>
         </p:txBody>
       </p:sp>
@@ -11160,7 +10871,6 @@
           <a:lstStyle/>
           <a:p>
             <a:pPr algn="ctr"/>
-            <a:endParaRPr/>
           </a:p>
         </p:txBody>
       </p:sp>
@@ -11204,7 +10914,6 @@
           <a:lstStyle/>
           <a:p>
             <a:pPr algn="ctr"/>
-            <a:endParaRPr/>
           </a:p>
         </p:txBody>
       </p:sp>
@@ -11287,7 +10996,7 @@
 </file>
 
 <file path=ppt/slides/slide18.xml><?xml version="1.0" encoding="utf-8"?>
-<p:sld xmlns:a="http://schemas.openxmlformats.org/drawingml/2006/main" xmlns:r="http://schemas.openxmlformats.org/officeDocument/2006/relationships" xmlns:p="http://schemas.openxmlformats.org/presentationml/2006/main">
+<p:sld xmlns:a="http://schemas.openxmlformats.org/drawingml/2006/main" xmlns:p="http://schemas.openxmlformats.org/presentationml/2006/main" xmlns:r="http://schemas.openxmlformats.org/officeDocument/2006/relationships">
   <p:cSld>
     <p:bg>
       <p:bgPr>
@@ -11303,14 +11012,7 @@
         <p:cNvGrpSpPr/>
         <p:nvPr/>
       </p:nvGrpSpPr>
-      <p:grpSpPr>
-        <a:xfrm>
-          <a:off x="0" y="0"/>
-          <a:ext cx="0" cy="0"/>
-          <a:chOff x="0" y="0"/>
-          <a:chExt cx="0" cy="0"/>
-        </a:xfrm>
-      </p:grpSpPr>
+      <p:grpSpPr/>
       <p:sp>
         <p:nvSpPr>
           <p:cNvPr id="2" name="TextBox 1"/>
@@ -11386,7 +11088,6 @@
           <a:lstStyle/>
           <a:p>
             <a:pPr algn="ctr"/>
-            <a:endParaRPr/>
           </a:p>
         </p:txBody>
       </p:sp>
@@ -11441,8 +11142,8 @@
         </p:blipFill>
         <p:spPr>
           <a:xfrm>
-            <a:off x="868680" y="1325880"/>
-            <a:ext cx="10241280" cy="2148840"/>
+            <a:off x="4079239" y="1325880"/>
+            <a:ext cx="3820160" cy="2148840"/>
           </a:xfrm>
           <a:prstGeom prst="rect">
             <a:avLst/>
@@ -11489,7 +11190,6 @@
           <a:lstStyle/>
           <a:p>
             <a:pPr algn="ctr"/>
-            <a:endParaRPr/>
           </a:p>
         </p:txBody>
       </p:sp>
@@ -11638,7 +11338,6 @@
           <a:lstStyle/>
           <a:p>
             <a:pPr algn="ctr"/>
-            <a:endParaRPr/>
           </a:p>
         </p:txBody>
       </p:sp>
@@ -11787,7 +11486,6 @@
           <a:lstStyle/>
           <a:p>
             <a:pPr algn="ctr"/>
-            <a:endParaRPr/>
           </a:p>
         </p:txBody>
       </p:sp>
@@ -11936,7 +11634,6 @@
           <a:lstStyle/>
           <a:p>
             <a:pPr algn="ctr"/>
-            <a:endParaRPr/>
           </a:p>
         </p:txBody>
       </p:sp>
@@ -12085,7 +11782,6 @@
           <a:lstStyle/>
           <a:p>
             <a:pPr algn="ctr"/>
-            <a:endParaRPr/>
           </a:p>
         </p:txBody>
       </p:sp>
@@ -12234,7 +11930,6 @@
           <a:lstStyle/>
           <a:p>
             <a:pPr algn="ctr"/>
-            <a:endParaRPr/>
           </a:p>
         </p:txBody>
       </p:sp>
@@ -12383,7 +12078,6 @@
           <a:lstStyle/>
           <a:p>
             <a:pPr algn="ctr"/>
-            <a:endParaRPr/>
           </a:p>
         </p:txBody>
       </p:sp>
@@ -12499,7 +12193,6 @@
           <a:lstStyle/>
           <a:p>
             <a:pPr algn="ctr"/>
-            <a:endParaRPr/>
           </a:p>
         </p:txBody>
       </p:sp>
@@ -12613,7 +12306,6 @@
           <a:lstStyle/>
           <a:p>
             <a:pPr algn="ctr"/>
-            <a:endParaRPr/>
           </a:p>
         </p:txBody>
       </p:sp>
@@ -12657,7 +12349,6 @@
           <a:lstStyle/>
           <a:p>
             <a:pPr algn="ctr"/>
-            <a:endParaRPr/>
           </a:p>
         </p:txBody>
       </p:sp>
@@ -12701,7 +12392,6 @@
           <a:lstStyle/>
           <a:p>
             <a:pPr algn="ctr"/>
-            <a:endParaRPr/>
           </a:p>
         </p:txBody>
       </p:sp>
@@ -12745,7 +12435,6 @@
           <a:lstStyle/>
           <a:p>
             <a:pPr algn="ctr"/>
-            <a:endParaRPr/>
           </a:p>
         </p:txBody>
       </p:sp>
@@ -12789,7 +12478,6 @@
           <a:lstStyle/>
           <a:p>
             <a:pPr algn="ctr"/>
-            <a:endParaRPr/>
           </a:p>
         </p:txBody>
       </p:sp>
@@ -12833,7 +12521,6 @@
           <a:lstStyle/>
           <a:p>
             <a:pPr algn="ctr"/>
-            <a:endParaRPr/>
           </a:p>
         </p:txBody>
       </p:sp>
@@ -12877,7 +12564,6 @@
           <a:lstStyle/>
           <a:p>
             <a:pPr algn="ctr"/>
-            <a:endParaRPr/>
           </a:p>
         </p:txBody>
       </p:sp>
@@ -12960,7 +12646,7 @@
 </file>
 
 <file path=ppt/slides/slide19.xml><?xml version="1.0" encoding="utf-8"?>
-<p:sld xmlns:a="http://schemas.openxmlformats.org/drawingml/2006/main" xmlns:r="http://schemas.openxmlformats.org/officeDocument/2006/relationships" xmlns:p="http://schemas.openxmlformats.org/presentationml/2006/main">
+<p:sld xmlns:a="http://schemas.openxmlformats.org/drawingml/2006/main" xmlns:p="http://schemas.openxmlformats.org/presentationml/2006/main" xmlns:r="http://schemas.openxmlformats.org/officeDocument/2006/relationships">
   <p:cSld>
     <p:bg>
       <p:bgPr>
@@ -12976,14 +12662,7 @@
         <p:cNvGrpSpPr/>
         <p:nvPr/>
       </p:nvGrpSpPr>
-      <p:grpSpPr>
-        <a:xfrm>
-          <a:off x="0" y="0"/>
-          <a:ext cx="0" cy="0"/>
-          <a:chOff x="0" y="0"/>
-          <a:chExt cx="0" cy="0"/>
-        </a:xfrm>
-      </p:grpSpPr>
+      <p:grpSpPr/>
       <p:sp>
         <p:nvSpPr>
           <p:cNvPr id="2" name="TextBox 1"/>
@@ -13059,7 +12738,6 @@
           <a:lstStyle/>
           <a:p>
             <a:pPr algn="ctr"/>
-            <a:endParaRPr/>
           </a:p>
         </p:txBody>
       </p:sp>
@@ -13117,20 +12795,8 @@
                 <a:tableStyleId>{5C22544A-7EE6-4342-B048-85BDC9FD1C3A}</a:tableStyleId>
               </a:tblPr>
               <a:tblGrid>
-                <a:gridCol w="2743200">
-                  <a:extLst>
-                    <a:ext uri="{9D8B030D-6E8A-4147-A177-3AD203B41FA5}">
-                      <a16:colId xmlns:a16="http://schemas.microsoft.com/office/drawing/2014/main" val="20000"/>
-                    </a:ext>
-                  </a:extLst>
-                </a:gridCol>
-                <a:gridCol w="7726679">
-                  <a:extLst>
-                    <a:ext uri="{9D8B030D-6E8A-4147-A177-3AD203B41FA5}">
-                      <a16:colId xmlns:a16="http://schemas.microsoft.com/office/drawing/2014/main" val="20001"/>
-                    </a:ext>
-                  </a:extLst>
-                </a:gridCol>
+                <a:gridCol w="2743200"/>
+                <a:gridCol w="7726679"/>
               </a:tblGrid>
               <a:tr h="548640">
                 <a:tc>
@@ -13177,11 +12843,6 @@
                     </a:solidFill>
                   </a:tcPr>
                 </a:tc>
-                <a:extLst>
-                  <a:ext uri="{0D108BD9-81ED-4DB2-BD59-A6C34878D82A}">
-                    <a16:rowId xmlns:a16="http://schemas.microsoft.com/office/drawing/2014/main" val="10000"/>
-                  </a:ext>
-                </a:extLst>
               </a:tr>
               <a:tr h="548640">
                 <a:tc>
@@ -13228,11 +12889,6 @@
                     </a:solidFill>
                   </a:tcPr>
                 </a:tc>
-                <a:extLst>
-                  <a:ext uri="{0D108BD9-81ED-4DB2-BD59-A6C34878D82A}">
-                    <a16:rowId xmlns:a16="http://schemas.microsoft.com/office/drawing/2014/main" val="10001"/>
-                  </a:ext>
-                </a:extLst>
               </a:tr>
               <a:tr h="548640">
                 <a:tc>
@@ -13279,11 +12935,6 @@
                     </a:solidFill>
                   </a:tcPr>
                 </a:tc>
-                <a:extLst>
-                  <a:ext uri="{0D108BD9-81ED-4DB2-BD59-A6C34878D82A}">
-                    <a16:rowId xmlns:a16="http://schemas.microsoft.com/office/drawing/2014/main" val="10002"/>
-                  </a:ext>
-                </a:extLst>
               </a:tr>
               <a:tr h="548640">
                 <a:tc>
@@ -13330,11 +12981,6 @@
                     </a:solidFill>
                   </a:tcPr>
                 </a:tc>
-                <a:extLst>
-                  <a:ext uri="{0D108BD9-81ED-4DB2-BD59-A6C34878D82A}">
-                    <a16:rowId xmlns:a16="http://schemas.microsoft.com/office/drawing/2014/main" val="10003"/>
-                  </a:ext>
-                </a:extLst>
               </a:tr>
               <a:tr h="548640">
                 <a:tc>
@@ -13381,11 +13027,6 @@
                     </a:solidFill>
                   </a:tcPr>
                 </a:tc>
-                <a:extLst>
-                  <a:ext uri="{0D108BD9-81ED-4DB2-BD59-A6C34878D82A}">
-                    <a16:rowId xmlns:a16="http://schemas.microsoft.com/office/drawing/2014/main" val="10004"/>
-                  </a:ext>
-                </a:extLst>
               </a:tr>
               <a:tr h="548640">
                 <a:tc>
@@ -13432,11 +13073,6 @@
                     </a:solidFill>
                   </a:tcPr>
                 </a:tc>
-                <a:extLst>
-                  <a:ext uri="{0D108BD9-81ED-4DB2-BD59-A6C34878D82A}">
-                    <a16:rowId xmlns:a16="http://schemas.microsoft.com/office/drawing/2014/main" val="10005"/>
-                  </a:ext>
-                </a:extLst>
               </a:tr>
               <a:tr h="548640">
                 <a:tc>
@@ -13483,11 +13119,6 @@
                     </a:solidFill>
                   </a:tcPr>
                 </a:tc>
-                <a:extLst>
-                  <a:ext uri="{0D108BD9-81ED-4DB2-BD59-A6C34878D82A}">
-                    <a16:rowId xmlns:a16="http://schemas.microsoft.com/office/drawing/2014/main" val="10006"/>
-                  </a:ext>
-                </a:extLst>
               </a:tr>
               <a:tr h="548640">
                 <a:tc>
@@ -13534,11 +13165,6 @@
                     </a:solidFill>
                   </a:tcPr>
                 </a:tc>
-                <a:extLst>
-                  <a:ext uri="{0D108BD9-81ED-4DB2-BD59-A6C34878D82A}">
-                    <a16:rowId xmlns:a16="http://schemas.microsoft.com/office/drawing/2014/main" val="10007"/>
-                  </a:ext>
-                </a:extLst>
               </a:tr>
             </a:tbl>
           </a:graphicData>
@@ -13584,7 +13210,6 @@
           <a:lstStyle/>
           <a:p>
             <a:pPr algn="ctr"/>
-            <a:endParaRPr/>
           </a:p>
         </p:txBody>
       </p:sp>
@@ -13628,7 +13253,6 @@
           <a:lstStyle/>
           <a:p>
             <a:pPr algn="ctr"/>
-            <a:endParaRPr/>
           </a:p>
         </p:txBody>
       </p:sp>
@@ -13672,7 +13296,6 @@
           <a:lstStyle/>
           <a:p>
             <a:pPr algn="ctr"/>
-            <a:endParaRPr/>
           </a:p>
         </p:txBody>
       </p:sp>
@@ -13716,7 +13339,6 @@
           <a:lstStyle/>
           <a:p>
             <a:pPr algn="ctr"/>
-            <a:endParaRPr/>
           </a:p>
         </p:txBody>
       </p:sp>
@@ -13760,7 +13382,6 @@
           <a:lstStyle/>
           <a:p>
             <a:pPr algn="ctr"/>
-            <a:endParaRPr/>
           </a:p>
         </p:txBody>
       </p:sp>
@@ -13804,7 +13425,6 @@
           <a:lstStyle/>
           <a:p>
             <a:pPr algn="ctr"/>
-            <a:endParaRPr/>
           </a:p>
         </p:txBody>
       </p:sp>
@@ -13848,7 +13468,6 @@
           <a:lstStyle/>
           <a:p>
             <a:pPr algn="ctr"/>
-            <a:endParaRPr/>
           </a:p>
         </p:txBody>
       </p:sp>
@@ -13931,7 +13550,7 @@
 </file>
 
 <file path=ppt/slides/slide2.xml><?xml version="1.0" encoding="utf-8"?>
-<p:sld xmlns:a="http://schemas.openxmlformats.org/drawingml/2006/main" xmlns:r="http://schemas.openxmlformats.org/officeDocument/2006/relationships" xmlns:p="http://schemas.openxmlformats.org/presentationml/2006/main">
+<p:sld xmlns:a="http://schemas.openxmlformats.org/drawingml/2006/main" xmlns:p="http://schemas.openxmlformats.org/presentationml/2006/main" xmlns:r="http://schemas.openxmlformats.org/officeDocument/2006/relationships">
   <p:cSld>
     <p:bg>
       <p:bgPr>
@@ -13947,14 +13566,7 @@
         <p:cNvGrpSpPr/>
         <p:nvPr/>
       </p:nvGrpSpPr>
-      <p:grpSpPr>
-        <a:xfrm>
-          <a:off x="0" y="0"/>
-          <a:ext cx="0" cy="0"/>
-          <a:chOff x="0" y="0"/>
-          <a:chExt cx="0" cy="0"/>
-        </a:xfrm>
-      </p:grpSpPr>
+      <p:grpSpPr/>
       <p:sp>
         <p:nvSpPr>
           <p:cNvPr id="2" name="TextBox 1"/>
@@ -14030,7 +13642,6 @@
           <a:lstStyle/>
           <a:p>
             <a:pPr algn="ctr"/>
-            <a:endParaRPr/>
           </a:p>
         </p:txBody>
       </p:sp>
@@ -14109,7 +13720,6 @@
           <a:lstStyle/>
           <a:p>
             <a:pPr algn="ctr"/>
-            <a:endParaRPr/>
           </a:p>
         </p:txBody>
       </p:sp>
@@ -14190,7 +13800,6 @@
           <a:lstStyle/>
           <a:p>
             <a:pPr algn="ctr"/>
-            <a:endParaRPr/>
           </a:p>
         </p:txBody>
       </p:sp>
@@ -14304,7 +13913,6 @@
           <a:lstStyle/>
           <a:p>
             <a:pPr algn="ctr"/>
-            <a:endParaRPr/>
           </a:p>
         </p:txBody>
       </p:sp>
@@ -14385,7 +13993,6 @@
           <a:lstStyle/>
           <a:p>
             <a:pPr algn="ctr"/>
-            <a:endParaRPr/>
           </a:p>
         </p:txBody>
       </p:sp>
@@ -14499,7 +14106,6 @@
           <a:lstStyle/>
           <a:p>
             <a:pPr algn="ctr"/>
-            <a:endParaRPr/>
           </a:p>
         </p:txBody>
       </p:sp>
@@ -14580,7 +14186,6 @@
           <a:lstStyle/>
           <a:p>
             <a:pPr algn="ctr"/>
-            <a:endParaRPr/>
           </a:p>
         </p:txBody>
       </p:sp>
@@ -14694,7 +14299,6 @@
           <a:lstStyle/>
           <a:p>
             <a:pPr algn="ctr"/>
-            <a:endParaRPr/>
           </a:p>
         </p:txBody>
       </p:sp>
@@ -14775,7 +14379,6 @@
           <a:lstStyle/>
           <a:p>
             <a:pPr algn="ctr"/>
-            <a:endParaRPr/>
           </a:p>
         </p:txBody>
       </p:sp>
@@ -14889,7 +14492,6 @@
           <a:lstStyle/>
           <a:p>
             <a:pPr algn="ctr"/>
-            <a:endParaRPr/>
           </a:p>
         </p:txBody>
       </p:sp>
@@ -14970,7 +14572,6 @@
           <a:lstStyle/>
           <a:p>
             <a:pPr algn="ctr"/>
-            <a:endParaRPr/>
           </a:p>
         </p:txBody>
       </p:sp>
@@ -15084,7 +14685,6 @@
           <a:lstStyle/>
           <a:p>
             <a:pPr algn="ctr"/>
-            <a:endParaRPr/>
           </a:p>
         </p:txBody>
       </p:sp>
@@ -15165,7 +14765,6 @@
           <a:lstStyle/>
           <a:p>
             <a:pPr algn="ctr"/>
-            <a:endParaRPr/>
           </a:p>
         </p:txBody>
       </p:sp>
@@ -15279,7 +14878,6 @@
           <a:lstStyle/>
           <a:p>
             <a:pPr algn="ctr"/>
-            <a:endParaRPr/>
           </a:p>
         </p:txBody>
       </p:sp>
@@ -15323,7 +14921,6 @@
           <a:lstStyle/>
           <a:p>
             <a:pPr algn="ctr"/>
-            <a:endParaRPr/>
           </a:p>
         </p:txBody>
       </p:sp>
@@ -15367,7 +14964,6 @@
           <a:lstStyle/>
           <a:p>
             <a:pPr algn="ctr"/>
-            <a:endParaRPr/>
           </a:p>
         </p:txBody>
       </p:sp>
@@ -15411,7 +15007,6 @@
           <a:lstStyle/>
           <a:p>
             <a:pPr algn="ctr"/>
-            <a:endParaRPr/>
           </a:p>
         </p:txBody>
       </p:sp>
@@ -15455,7 +15050,6 @@
           <a:lstStyle/>
           <a:p>
             <a:pPr algn="ctr"/>
-            <a:endParaRPr/>
           </a:p>
         </p:txBody>
       </p:sp>
@@ -15499,7 +15093,6 @@
           <a:lstStyle/>
           <a:p>
             <a:pPr algn="ctr"/>
-            <a:endParaRPr/>
           </a:p>
         </p:txBody>
       </p:sp>
@@ -15543,7 +15136,6 @@
           <a:lstStyle/>
           <a:p>
             <a:pPr algn="ctr"/>
-            <a:endParaRPr/>
           </a:p>
         </p:txBody>
       </p:sp>
@@ -15626,7 +15218,7 @@
 </file>
 
 <file path=ppt/slides/slide20.xml><?xml version="1.0" encoding="utf-8"?>
-<p:sld xmlns:a="http://schemas.openxmlformats.org/drawingml/2006/main" xmlns:r="http://schemas.openxmlformats.org/officeDocument/2006/relationships" xmlns:p="http://schemas.openxmlformats.org/presentationml/2006/main">
+<p:sld xmlns:a="http://schemas.openxmlformats.org/drawingml/2006/main" xmlns:p="http://schemas.openxmlformats.org/presentationml/2006/main" xmlns:r="http://schemas.openxmlformats.org/officeDocument/2006/relationships">
   <p:cSld>
     <p:bg>
       <p:bgPr>
@@ -15642,14 +15234,7 @@
         <p:cNvGrpSpPr/>
         <p:nvPr/>
       </p:nvGrpSpPr>
-      <p:grpSpPr>
-        <a:xfrm>
-          <a:off x="0" y="0"/>
-          <a:ext cx="0" cy="0"/>
-          <a:chOff x="0" y="0"/>
-          <a:chExt cx="0" cy="0"/>
-        </a:xfrm>
-      </p:grpSpPr>
+      <p:grpSpPr/>
       <p:sp>
         <p:nvSpPr>
           <p:cNvPr id="2" name="TextBox 1"/>
@@ -15725,7 +15310,6 @@
           <a:lstStyle/>
           <a:p>
             <a:pPr algn="ctr"/>
-            <a:endParaRPr/>
           </a:p>
         </p:txBody>
       </p:sp>
@@ -15806,7 +15390,6 @@
           <a:lstStyle/>
           <a:p>
             <a:pPr algn="ctr"/>
-            <a:endParaRPr/>
           </a:p>
         </p:txBody>
       </p:sp>
@@ -15942,7 +15525,6 @@
           <a:lstStyle/>
           <a:p>
             <a:pPr algn="ctr"/>
-            <a:endParaRPr/>
           </a:p>
         </p:txBody>
       </p:sp>
@@ -16088,7 +15670,6 @@
           <a:lstStyle/>
           <a:p>
             <a:pPr algn="ctr"/>
-            <a:endParaRPr/>
           </a:p>
         </p:txBody>
       </p:sp>
@@ -16232,7 +15813,6 @@
           <a:lstStyle/>
           <a:p>
             <a:pPr algn="ctr"/>
-            <a:endParaRPr/>
           </a:p>
         </p:txBody>
       </p:sp>
@@ -16276,7 +15856,6 @@
           <a:lstStyle/>
           <a:p>
             <a:pPr algn="ctr"/>
-            <a:endParaRPr/>
           </a:p>
         </p:txBody>
       </p:sp>
@@ -16320,7 +15899,6 @@
           <a:lstStyle/>
           <a:p>
             <a:pPr algn="ctr"/>
-            <a:endParaRPr/>
           </a:p>
         </p:txBody>
       </p:sp>
@@ -16364,7 +15942,6 @@
           <a:lstStyle/>
           <a:p>
             <a:pPr algn="ctr"/>
-            <a:endParaRPr/>
           </a:p>
         </p:txBody>
       </p:sp>
@@ -16408,7 +15985,6 @@
           <a:lstStyle/>
           <a:p>
             <a:pPr algn="ctr"/>
-            <a:endParaRPr/>
           </a:p>
         </p:txBody>
       </p:sp>
@@ -16452,7 +16028,6 @@
           <a:lstStyle/>
           <a:p>
             <a:pPr algn="ctr"/>
-            <a:endParaRPr/>
           </a:p>
         </p:txBody>
       </p:sp>
@@ -16496,7 +16071,6 @@
           <a:lstStyle/>
           <a:p>
             <a:pPr algn="ctr"/>
-            <a:endParaRPr/>
           </a:p>
         </p:txBody>
       </p:sp>
@@ -16579,7 +16153,7 @@
 </file>
 
 <file path=ppt/slides/slide21.xml><?xml version="1.0" encoding="utf-8"?>
-<p:sld xmlns:a="http://schemas.openxmlformats.org/drawingml/2006/main" xmlns:r="http://schemas.openxmlformats.org/officeDocument/2006/relationships" xmlns:p="http://schemas.openxmlformats.org/presentationml/2006/main">
+<p:sld xmlns:a="http://schemas.openxmlformats.org/drawingml/2006/main" xmlns:p="http://schemas.openxmlformats.org/presentationml/2006/main" xmlns:r="http://schemas.openxmlformats.org/officeDocument/2006/relationships">
   <p:cSld>
     <p:bg>
       <p:bgPr>
@@ -16595,14 +16169,7 @@
         <p:cNvGrpSpPr/>
         <p:nvPr/>
       </p:nvGrpSpPr>
-      <p:grpSpPr>
-        <a:xfrm>
-          <a:off x="0" y="0"/>
-          <a:ext cx="0" cy="0"/>
-          <a:chOff x="0" y="0"/>
-          <a:chExt cx="0" cy="0"/>
-        </a:xfrm>
-      </p:grpSpPr>
+      <p:grpSpPr/>
       <p:sp>
         <p:nvSpPr>
           <p:cNvPr id="2" name="TextBox 1"/>
@@ -16678,7 +16245,6 @@
           <a:lstStyle/>
           <a:p>
             <a:pPr algn="ctr"/>
-            <a:endParaRPr/>
           </a:p>
         </p:txBody>
       </p:sp>
@@ -16759,7 +16325,6 @@
           <a:lstStyle/>
           <a:p>
             <a:pPr algn="ctr"/>
-            <a:endParaRPr/>
           </a:p>
         </p:txBody>
       </p:sp>
@@ -16895,7 +16460,6 @@
           <a:lstStyle/>
           <a:p>
             <a:pPr algn="ctr"/>
-            <a:endParaRPr/>
           </a:p>
         </p:txBody>
       </p:sp>
@@ -17031,7 +16595,6 @@
           <a:lstStyle/>
           <a:p>
             <a:pPr algn="ctr"/>
-            <a:endParaRPr/>
           </a:p>
         </p:txBody>
       </p:sp>
@@ -17167,7 +16730,6 @@
           <a:lstStyle/>
           <a:p>
             <a:pPr algn="ctr"/>
-            <a:endParaRPr/>
           </a:p>
         </p:txBody>
       </p:sp>
@@ -17301,7 +16863,6 @@
           <a:lstStyle/>
           <a:p>
             <a:pPr algn="ctr"/>
-            <a:endParaRPr/>
           </a:p>
         </p:txBody>
       </p:sp>
@@ -17345,7 +16906,6 @@
           <a:lstStyle/>
           <a:p>
             <a:pPr algn="ctr"/>
-            <a:endParaRPr/>
           </a:p>
         </p:txBody>
       </p:sp>
@@ -17389,7 +16949,6 @@
           <a:lstStyle/>
           <a:p>
             <a:pPr algn="ctr"/>
-            <a:endParaRPr/>
           </a:p>
         </p:txBody>
       </p:sp>
@@ -17433,7 +16992,6 @@
           <a:lstStyle/>
           <a:p>
             <a:pPr algn="ctr"/>
-            <a:endParaRPr/>
           </a:p>
         </p:txBody>
       </p:sp>
@@ -17477,7 +17035,6 @@
           <a:lstStyle/>
           <a:p>
             <a:pPr algn="ctr"/>
-            <a:endParaRPr/>
           </a:p>
         </p:txBody>
       </p:sp>
@@ -17521,7 +17078,6 @@
           <a:lstStyle/>
           <a:p>
             <a:pPr algn="ctr"/>
-            <a:endParaRPr/>
           </a:p>
         </p:txBody>
       </p:sp>
@@ -17565,7 +17121,6 @@
           <a:lstStyle/>
           <a:p>
             <a:pPr algn="ctr"/>
-            <a:endParaRPr/>
           </a:p>
         </p:txBody>
       </p:sp>
@@ -17648,7 +17203,7 @@
 </file>
 
 <file path=ppt/slides/slide3.xml><?xml version="1.0" encoding="utf-8"?>
-<p:sld xmlns:a="http://schemas.openxmlformats.org/drawingml/2006/main" xmlns:r="http://schemas.openxmlformats.org/officeDocument/2006/relationships" xmlns:p="http://schemas.openxmlformats.org/presentationml/2006/main">
+<p:sld xmlns:a="http://schemas.openxmlformats.org/drawingml/2006/main" xmlns:p="http://schemas.openxmlformats.org/presentationml/2006/main" xmlns:r="http://schemas.openxmlformats.org/officeDocument/2006/relationships">
   <p:cSld>
     <p:bg>
       <p:bgPr>
@@ -17664,14 +17219,7 @@
         <p:cNvGrpSpPr/>
         <p:nvPr/>
       </p:nvGrpSpPr>
-      <p:grpSpPr>
-        <a:xfrm>
-          <a:off x="0" y="0"/>
-          <a:ext cx="0" cy="0"/>
-          <a:chOff x="0" y="0"/>
-          <a:chExt cx="0" cy="0"/>
-        </a:xfrm>
-      </p:grpSpPr>
+      <p:grpSpPr/>
       <p:sp>
         <p:nvSpPr>
           <p:cNvPr id="2" name="TextBox 1"/>
@@ -17747,7 +17295,6 @@
           <a:lstStyle/>
           <a:p>
             <a:pPr algn="ctr"/>
-            <a:endParaRPr/>
           </a:p>
         </p:txBody>
       </p:sp>
@@ -17828,7 +17375,6 @@
           <a:lstStyle/>
           <a:p>
             <a:pPr algn="ctr"/>
-            <a:endParaRPr/>
           </a:p>
         </p:txBody>
       </p:sp>
@@ -17984,7 +17530,6 @@
           <a:lstStyle/>
           <a:p>
             <a:pPr algn="ctr"/>
-            <a:endParaRPr/>
           </a:p>
         </p:txBody>
       </p:sp>
@@ -18138,7 +17683,6 @@
           <a:lstStyle/>
           <a:p>
             <a:pPr algn="ctr"/>
-            <a:endParaRPr/>
           </a:p>
         </p:txBody>
       </p:sp>
@@ -18182,7 +17726,6 @@
           <a:lstStyle/>
           <a:p>
             <a:pPr algn="ctr"/>
-            <a:endParaRPr/>
           </a:p>
         </p:txBody>
       </p:sp>
@@ -18226,7 +17769,6 @@
           <a:lstStyle/>
           <a:p>
             <a:pPr algn="ctr"/>
-            <a:endParaRPr/>
           </a:p>
         </p:txBody>
       </p:sp>
@@ -18270,7 +17812,6 @@
           <a:lstStyle/>
           <a:p>
             <a:pPr algn="ctr"/>
-            <a:endParaRPr/>
           </a:p>
         </p:txBody>
       </p:sp>
@@ -18314,7 +17855,6 @@
           <a:lstStyle/>
           <a:p>
             <a:pPr algn="ctr"/>
-            <a:endParaRPr/>
           </a:p>
         </p:txBody>
       </p:sp>
@@ -18358,7 +17898,6 @@
           <a:lstStyle/>
           <a:p>
             <a:pPr algn="ctr"/>
-            <a:endParaRPr/>
           </a:p>
         </p:txBody>
       </p:sp>
@@ -18402,7 +17941,6 @@
           <a:lstStyle/>
           <a:p>
             <a:pPr algn="ctr"/>
-            <a:endParaRPr/>
           </a:p>
         </p:txBody>
       </p:sp>
@@ -18485,7 +18023,7 @@
 </file>
 
 <file path=ppt/slides/slide4.xml><?xml version="1.0" encoding="utf-8"?>
-<p:sld xmlns:a="http://schemas.openxmlformats.org/drawingml/2006/main" xmlns:r="http://schemas.openxmlformats.org/officeDocument/2006/relationships" xmlns:p="http://schemas.openxmlformats.org/presentationml/2006/main">
+<p:sld xmlns:a="http://schemas.openxmlformats.org/drawingml/2006/main" xmlns:p="http://schemas.openxmlformats.org/presentationml/2006/main" xmlns:r="http://schemas.openxmlformats.org/officeDocument/2006/relationships">
   <p:cSld>
     <p:bg>
       <p:bgPr>
@@ -18501,14 +18039,7 @@
         <p:cNvGrpSpPr/>
         <p:nvPr/>
       </p:nvGrpSpPr>
-      <p:grpSpPr>
-        <a:xfrm>
-          <a:off x="0" y="0"/>
-          <a:ext cx="0" cy="0"/>
-          <a:chOff x="0" y="0"/>
-          <a:chExt cx="0" cy="0"/>
-        </a:xfrm>
-      </p:grpSpPr>
+      <p:grpSpPr/>
       <p:sp>
         <p:nvSpPr>
           <p:cNvPr id="2" name="TextBox 1"/>
@@ -18584,7 +18115,6 @@
           <a:lstStyle/>
           <a:p>
             <a:pPr algn="ctr"/>
-            <a:endParaRPr/>
           </a:p>
         </p:txBody>
       </p:sp>
@@ -18665,7 +18195,6 @@
           <a:lstStyle/>
           <a:p>
             <a:pPr algn="ctr"/>
-            <a:endParaRPr/>
           </a:p>
         </p:txBody>
       </p:sp>
@@ -18811,7 +18340,6 @@
           <a:lstStyle/>
           <a:p>
             <a:pPr algn="ctr"/>
-            <a:endParaRPr/>
           </a:p>
         </p:txBody>
       </p:sp>
@@ -18937,7 +18465,6 @@
           <a:lstStyle/>
           <a:p>
             <a:pPr algn="ctr"/>
-            <a:endParaRPr/>
           </a:p>
         </p:txBody>
       </p:sp>
@@ -19091,7 +18618,6 @@
           <a:lstStyle/>
           <a:p>
             <a:pPr algn="ctr"/>
-            <a:endParaRPr/>
           </a:p>
         </p:txBody>
       </p:sp>
@@ -19135,7 +18661,6 @@
           <a:lstStyle/>
           <a:p>
             <a:pPr algn="ctr"/>
-            <a:endParaRPr/>
           </a:p>
         </p:txBody>
       </p:sp>
@@ -19179,7 +18704,6 @@
           <a:lstStyle/>
           <a:p>
             <a:pPr algn="ctr"/>
-            <a:endParaRPr/>
           </a:p>
         </p:txBody>
       </p:sp>
@@ -19223,7 +18747,6 @@
           <a:lstStyle/>
           <a:p>
             <a:pPr algn="ctr"/>
-            <a:endParaRPr/>
           </a:p>
         </p:txBody>
       </p:sp>
@@ -19267,7 +18790,6 @@
           <a:lstStyle/>
           <a:p>
             <a:pPr algn="ctr"/>
-            <a:endParaRPr/>
           </a:p>
         </p:txBody>
       </p:sp>
@@ -19311,7 +18833,6 @@
           <a:lstStyle/>
           <a:p>
             <a:pPr algn="ctr"/>
-            <a:endParaRPr/>
           </a:p>
         </p:txBody>
       </p:sp>
@@ -19355,7 +18876,6 @@
           <a:lstStyle/>
           <a:p>
             <a:pPr algn="ctr"/>
-            <a:endParaRPr/>
           </a:p>
         </p:txBody>
       </p:sp>
@@ -19438,7 +18958,7 @@
 </file>
 
 <file path=ppt/slides/slide5.xml><?xml version="1.0" encoding="utf-8"?>
-<p:sld xmlns:a="http://schemas.openxmlformats.org/drawingml/2006/main" xmlns:r="http://schemas.openxmlformats.org/officeDocument/2006/relationships" xmlns:p="http://schemas.openxmlformats.org/presentationml/2006/main">
+<p:sld xmlns:a="http://schemas.openxmlformats.org/drawingml/2006/main" xmlns:p="http://schemas.openxmlformats.org/presentationml/2006/main" xmlns:r="http://schemas.openxmlformats.org/officeDocument/2006/relationships">
   <p:cSld>
     <p:bg>
       <p:bgPr>
@@ -19454,14 +18974,7 @@
         <p:cNvGrpSpPr/>
         <p:nvPr/>
       </p:nvGrpSpPr>
-      <p:grpSpPr>
-        <a:xfrm>
-          <a:off x="0" y="0"/>
-          <a:ext cx="0" cy="0"/>
-          <a:chOff x="0" y="0"/>
-          <a:chExt cx="0" cy="0"/>
-        </a:xfrm>
-      </p:grpSpPr>
+      <p:grpSpPr/>
       <p:sp>
         <p:nvSpPr>
           <p:cNvPr id="2" name="TextBox 1"/>
@@ -19537,7 +19050,6 @@
           <a:lstStyle/>
           <a:p>
             <a:pPr algn="ctr"/>
-            <a:endParaRPr/>
           </a:p>
         </p:txBody>
       </p:sp>
@@ -19618,7 +19130,6 @@
           <a:lstStyle/>
           <a:p>
             <a:pPr algn="ctr"/>
-            <a:endParaRPr/>
           </a:p>
         </p:txBody>
       </p:sp>
@@ -19768,8 +19279,8 @@
         </p:blipFill>
         <p:spPr>
           <a:xfrm>
-            <a:off x="6217920" y="1325880"/>
-            <a:ext cx="5166360" cy="2926080"/>
+            <a:off x="6217920" y="1335881"/>
+            <a:ext cx="5166360" cy="2906077"/>
           </a:xfrm>
           <a:prstGeom prst="rect">
             <a:avLst/>
@@ -19818,7 +19329,6 @@
           <a:lstStyle/>
           <a:p>
             <a:pPr algn="ctr"/>
-            <a:endParaRPr/>
           </a:p>
         </p:txBody>
       </p:sp>
@@ -19942,7 +19452,6 @@
           <a:lstStyle/>
           <a:p>
             <a:pPr algn="ctr"/>
-            <a:endParaRPr/>
           </a:p>
         </p:txBody>
       </p:sp>
@@ -19986,7 +19495,6 @@
           <a:lstStyle/>
           <a:p>
             <a:pPr algn="ctr"/>
-            <a:endParaRPr/>
           </a:p>
         </p:txBody>
       </p:sp>
@@ -20030,7 +19538,6 @@
           <a:lstStyle/>
           <a:p>
             <a:pPr algn="ctr"/>
-            <a:endParaRPr/>
           </a:p>
         </p:txBody>
       </p:sp>
@@ -20074,7 +19581,6 @@
           <a:lstStyle/>
           <a:p>
             <a:pPr algn="ctr"/>
-            <a:endParaRPr/>
           </a:p>
         </p:txBody>
       </p:sp>
@@ -20118,7 +19624,6 @@
           <a:lstStyle/>
           <a:p>
             <a:pPr algn="ctr"/>
-            <a:endParaRPr/>
           </a:p>
         </p:txBody>
       </p:sp>
@@ -20162,7 +19667,6 @@
           <a:lstStyle/>
           <a:p>
             <a:pPr algn="ctr"/>
-            <a:endParaRPr/>
           </a:p>
         </p:txBody>
       </p:sp>
@@ -20206,7 +19710,6 @@
           <a:lstStyle/>
           <a:p>
             <a:pPr algn="ctr"/>
-            <a:endParaRPr/>
           </a:p>
         </p:txBody>
       </p:sp>
@@ -20289,7 +19792,7 @@
 </file>
 
 <file path=ppt/slides/slide6.xml><?xml version="1.0" encoding="utf-8"?>
-<p:sld xmlns:a="http://schemas.openxmlformats.org/drawingml/2006/main" xmlns:r="http://schemas.openxmlformats.org/officeDocument/2006/relationships" xmlns:p="http://schemas.openxmlformats.org/presentationml/2006/main">
+<p:sld xmlns:a="http://schemas.openxmlformats.org/drawingml/2006/main" xmlns:p="http://schemas.openxmlformats.org/presentationml/2006/main" xmlns:r="http://schemas.openxmlformats.org/officeDocument/2006/relationships">
   <p:cSld>
     <p:bg>
       <p:bgPr>
@@ -20305,14 +19808,7 @@
         <p:cNvGrpSpPr/>
         <p:nvPr/>
       </p:nvGrpSpPr>
-      <p:grpSpPr>
-        <a:xfrm>
-          <a:off x="0" y="0"/>
-          <a:ext cx="0" cy="0"/>
-          <a:chOff x="0" y="0"/>
-          <a:chExt cx="0" cy="0"/>
-        </a:xfrm>
-      </p:grpSpPr>
+      <p:grpSpPr/>
       <p:sp>
         <p:nvSpPr>
           <p:cNvPr id="2" name="TextBox 1"/>
@@ -20388,7 +19884,6 @@
           <a:lstStyle/>
           <a:p>
             <a:pPr algn="ctr"/>
-            <a:endParaRPr/>
           </a:p>
         </p:txBody>
       </p:sp>
@@ -20446,27 +19941,9 @@
                 <a:tableStyleId>{5C22544A-7EE6-4342-B048-85BDC9FD1C3A}</a:tableStyleId>
               </a:tblPr>
               <a:tblGrid>
-                <a:gridCol w="2926080">
-                  <a:extLst>
-                    <a:ext uri="{9D8B030D-6E8A-4147-A177-3AD203B41FA5}">
-                      <a16:colId xmlns:a16="http://schemas.microsoft.com/office/drawing/2014/main" val="20000"/>
-                    </a:ext>
-                  </a:extLst>
-                </a:gridCol>
-                <a:gridCol w="4297680">
-                  <a:extLst>
-                    <a:ext uri="{9D8B030D-6E8A-4147-A177-3AD203B41FA5}">
-                      <a16:colId xmlns:a16="http://schemas.microsoft.com/office/drawing/2014/main" val="20001"/>
-                    </a:ext>
-                  </a:extLst>
-                </a:gridCol>
-                <a:gridCol w="3749039">
-                  <a:extLst>
-                    <a:ext uri="{9D8B030D-6E8A-4147-A177-3AD203B41FA5}">
-                      <a16:colId xmlns:a16="http://schemas.microsoft.com/office/drawing/2014/main" val="20002"/>
-                    </a:ext>
-                  </a:extLst>
-                </a:gridCol>
+                <a:gridCol w="2926080"/>
+                <a:gridCol w="4297680"/>
+                <a:gridCol w="3749039"/>
               </a:tblGrid>
               <a:tr h="448056">
                 <a:tc>
@@ -20535,11 +20012,6 @@
                     </a:solidFill>
                   </a:tcPr>
                 </a:tc>
-                <a:extLst>
-                  <a:ext uri="{0D108BD9-81ED-4DB2-BD59-A6C34878D82A}">
-                    <a16:rowId xmlns:a16="http://schemas.microsoft.com/office/drawing/2014/main" val="10000"/>
-                  </a:ext>
-                </a:extLst>
               </a:tr>
               <a:tr h="448056">
                 <a:tc>
@@ -20608,11 +20080,6 @@
                     </a:solidFill>
                   </a:tcPr>
                 </a:tc>
-                <a:extLst>
-                  <a:ext uri="{0D108BD9-81ED-4DB2-BD59-A6C34878D82A}">
-                    <a16:rowId xmlns:a16="http://schemas.microsoft.com/office/drawing/2014/main" val="10001"/>
-                  </a:ext>
-                </a:extLst>
               </a:tr>
               <a:tr h="448056">
                 <a:tc>
@@ -20681,11 +20148,6 @@
                     </a:solidFill>
                   </a:tcPr>
                 </a:tc>
-                <a:extLst>
-                  <a:ext uri="{0D108BD9-81ED-4DB2-BD59-A6C34878D82A}">
-                    <a16:rowId xmlns:a16="http://schemas.microsoft.com/office/drawing/2014/main" val="10002"/>
-                  </a:ext>
-                </a:extLst>
               </a:tr>
               <a:tr h="448056">
                 <a:tc>
@@ -20754,11 +20216,6 @@
                     </a:solidFill>
                   </a:tcPr>
                 </a:tc>
-                <a:extLst>
-                  <a:ext uri="{0D108BD9-81ED-4DB2-BD59-A6C34878D82A}">
-                    <a16:rowId xmlns:a16="http://schemas.microsoft.com/office/drawing/2014/main" val="10003"/>
-                  </a:ext>
-                </a:extLst>
               </a:tr>
               <a:tr h="448056">
                 <a:tc>
@@ -20827,11 +20284,6 @@
                     </a:solidFill>
                   </a:tcPr>
                 </a:tc>
-                <a:extLst>
-                  <a:ext uri="{0D108BD9-81ED-4DB2-BD59-A6C34878D82A}">
-                    <a16:rowId xmlns:a16="http://schemas.microsoft.com/office/drawing/2014/main" val="10004"/>
-                  </a:ext>
-                </a:extLst>
               </a:tr>
             </a:tbl>
           </a:graphicData>
@@ -20853,8 +20305,8 @@
         </p:blipFill>
         <p:spPr>
           <a:xfrm>
-            <a:off x="777240" y="3657600"/>
-            <a:ext cx="4251960" cy="2395728"/>
+            <a:off x="777240" y="3659600"/>
+            <a:ext cx="4251960" cy="2391727"/>
           </a:xfrm>
           <a:prstGeom prst="rect">
             <a:avLst/>
@@ -20903,7 +20355,6 @@
           <a:lstStyle/>
           <a:p>
             <a:pPr algn="ctr"/>
-            <a:endParaRPr/>
           </a:p>
         </p:txBody>
       </p:sp>
@@ -21027,7 +20478,6 @@
           <a:lstStyle/>
           <a:p>
             <a:pPr algn="ctr"/>
-            <a:endParaRPr/>
           </a:p>
         </p:txBody>
       </p:sp>
@@ -21071,7 +20521,6 @@
           <a:lstStyle/>
           <a:p>
             <a:pPr algn="ctr"/>
-            <a:endParaRPr/>
           </a:p>
         </p:txBody>
       </p:sp>
@@ -21115,7 +20564,6 @@
           <a:lstStyle/>
           <a:p>
             <a:pPr algn="ctr"/>
-            <a:endParaRPr/>
           </a:p>
         </p:txBody>
       </p:sp>
@@ -21159,7 +20607,6 @@
           <a:lstStyle/>
           <a:p>
             <a:pPr algn="ctr"/>
-            <a:endParaRPr/>
           </a:p>
         </p:txBody>
       </p:sp>
@@ -21203,7 +20650,6 @@
           <a:lstStyle/>
           <a:p>
             <a:pPr algn="ctr"/>
-            <a:endParaRPr/>
           </a:p>
         </p:txBody>
       </p:sp>
@@ -21247,7 +20693,6 @@
           <a:lstStyle/>
           <a:p>
             <a:pPr algn="ctr"/>
-            <a:endParaRPr/>
           </a:p>
         </p:txBody>
       </p:sp>
@@ -21291,7 +20736,6 @@
           <a:lstStyle/>
           <a:p>
             <a:pPr algn="ctr"/>
-            <a:endParaRPr/>
           </a:p>
         </p:txBody>
       </p:sp>
@@ -21374,7 +20818,7 @@
 </file>
 
 <file path=ppt/slides/slide7.xml><?xml version="1.0" encoding="utf-8"?>
-<p:sld xmlns:a="http://schemas.openxmlformats.org/drawingml/2006/main" xmlns:r="http://schemas.openxmlformats.org/officeDocument/2006/relationships" xmlns:p="http://schemas.openxmlformats.org/presentationml/2006/main">
+<p:sld xmlns:a="http://schemas.openxmlformats.org/drawingml/2006/main" xmlns:p="http://schemas.openxmlformats.org/presentationml/2006/main" xmlns:r="http://schemas.openxmlformats.org/officeDocument/2006/relationships">
   <p:cSld>
     <p:bg>
       <p:bgPr>
@@ -21390,14 +20834,7 @@
         <p:cNvGrpSpPr/>
         <p:nvPr/>
       </p:nvGrpSpPr>
-      <p:grpSpPr>
-        <a:xfrm>
-          <a:off x="0" y="0"/>
-          <a:ext cx="0" cy="0"/>
-          <a:chOff x="0" y="0"/>
-          <a:chExt cx="0" cy="0"/>
-        </a:xfrm>
-      </p:grpSpPr>
+      <p:grpSpPr/>
       <p:sp>
         <p:nvSpPr>
           <p:cNvPr id="2" name="TextBox 1"/>
@@ -21473,7 +20910,6 @@
           <a:lstStyle/>
           <a:p>
             <a:pPr algn="ctr"/>
-            <a:endParaRPr/>
           </a:p>
         </p:txBody>
       </p:sp>
@@ -21528,8 +20964,8 @@
         </p:blipFill>
         <p:spPr>
           <a:xfrm>
-            <a:off x="685800" y="1417320"/>
-            <a:ext cx="5486400" cy="3090672"/>
+            <a:off x="685800" y="1419606"/>
+            <a:ext cx="5486400" cy="3086100"/>
           </a:xfrm>
           <a:prstGeom prst="rect">
             <a:avLst/>
@@ -21578,7 +21014,6 @@
           <a:lstStyle/>
           <a:p>
             <a:pPr algn="ctr"/>
-            <a:endParaRPr/>
           </a:p>
         </p:txBody>
       </p:sp>
@@ -21704,7 +21139,6 @@
           <a:lstStyle/>
           <a:p>
             <a:pPr algn="ctr"/>
-            <a:endParaRPr/>
           </a:p>
         </p:txBody>
       </p:sp>
@@ -21830,7 +21264,6 @@
           <a:lstStyle/>
           <a:p>
             <a:pPr algn="ctr"/>
-            <a:endParaRPr/>
           </a:p>
         </p:txBody>
       </p:sp>
@@ -21954,7 +21387,6 @@
           <a:lstStyle/>
           <a:p>
             <a:pPr algn="ctr"/>
-            <a:endParaRPr/>
           </a:p>
         </p:txBody>
       </p:sp>
@@ -21998,7 +21430,6 @@
           <a:lstStyle/>
           <a:p>
             <a:pPr algn="ctr"/>
-            <a:endParaRPr/>
           </a:p>
         </p:txBody>
       </p:sp>
@@ -22042,7 +21473,6 @@
           <a:lstStyle/>
           <a:p>
             <a:pPr algn="ctr"/>
-            <a:endParaRPr/>
           </a:p>
         </p:txBody>
       </p:sp>
@@ -22086,7 +21516,6 @@
           <a:lstStyle/>
           <a:p>
             <a:pPr algn="ctr"/>
-            <a:endParaRPr/>
           </a:p>
         </p:txBody>
       </p:sp>
@@ -22130,7 +21559,6 @@
           <a:lstStyle/>
           <a:p>
             <a:pPr algn="ctr"/>
-            <a:endParaRPr/>
           </a:p>
         </p:txBody>
       </p:sp>
@@ -22174,7 +21602,6 @@
           <a:lstStyle/>
           <a:p>
             <a:pPr algn="ctr"/>
-            <a:endParaRPr/>
           </a:p>
         </p:txBody>
       </p:sp>
@@ -22218,7 +21645,6 @@
           <a:lstStyle/>
           <a:p>
             <a:pPr algn="ctr"/>
-            <a:endParaRPr/>
           </a:p>
         </p:txBody>
       </p:sp>
@@ -22301,7 +21727,7 @@
 </file>
 
 <file path=ppt/slides/slide8.xml><?xml version="1.0" encoding="utf-8"?>
-<p:sld xmlns:a="http://schemas.openxmlformats.org/drawingml/2006/main" xmlns:r="http://schemas.openxmlformats.org/officeDocument/2006/relationships" xmlns:p="http://schemas.openxmlformats.org/presentationml/2006/main">
+<p:sld xmlns:a="http://schemas.openxmlformats.org/drawingml/2006/main" xmlns:p="http://schemas.openxmlformats.org/presentationml/2006/main" xmlns:r="http://schemas.openxmlformats.org/officeDocument/2006/relationships">
   <p:cSld>
     <p:bg>
       <p:bgPr>
@@ -22317,14 +21743,7 @@
         <p:cNvGrpSpPr/>
         <p:nvPr/>
       </p:nvGrpSpPr>
-      <p:grpSpPr>
-        <a:xfrm>
-          <a:off x="0" y="0"/>
-          <a:ext cx="0" cy="0"/>
-          <a:chOff x="0" y="0"/>
-          <a:chExt cx="0" cy="0"/>
-        </a:xfrm>
-      </p:grpSpPr>
+      <p:grpSpPr/>
       <p:sp>
         <p:nvSpPr>
           <p:cNvPr id="2" name="TextBox 1"/>
@@ -22400,7 +21819,6 @@
           <a:lstStyle/>
           <a:p>
             <a:pPr algn="ctr"/>
-            <a:endParaRPr/>
           </a:p>
         </p:txBody>
       </p:sp>
@@ -22458,27 +21876,9 @@
                 <a:tableStyleId>{5C22544A-7EE6-4342-B048-85BDC9FD1C3A}</a:tableStyleId>
               </a:tblPr>
               <a:tblGrid>
-                <a:gridCol w="1463040">
-                  <a:extLst>
-                    <a:ext uri="{9D8B030D-6E8A-4147-A177-3AD203B41FA5}">
-                      <a16:colId xmlns:a16="http://schemas.microsoft.com/office/drawing/2014/main" val="20000"/>
-                    </a:ext>
-                  </a:extLst>
-                </a:gridCol>
-                <a:gridCol w="4572000">
-                  <a:extLst>
-                    <a:ext uri="{9D8B030D-6E8A-4147-A177-3AD203B41FA5}">
-                      <a16:colId xmlns:a16="http://schemas.microsoft.com/office/drawing/2014/main" val="20001"/>
-                    </a:ext>
-                  </a:extLst>
-                </a:gridCol>
-                <a:gridCol w="5166360">
-                  <a:extLst>
-                    <a:ext uri="{9D8B030D-6E8A-4147-A177-3AD203B41FA5}">
-                      <a16:colId xmlns:a16="http://schemas.microsoft.com/office/drawing/2014/main" val="20002"/>
-                    </a:ext>
-                  </a:extLst>
-                </a:gridCol>
+                <a:gridCol w="1463040"/>
+                <a:gridCol w="4572000"/>
+                <a:gridCol w="5166360"/>
               </a:tblGrid>
               <a:tr h="600075">
                 <a:tc>
@@ -22547,11 +21947,6 @@
                     </a:solidFill>
                   </a:tcPr>
                 </a:tc>
-                <a:extLst>
-                  <a:ext uri="{0D108BD9-81ED-4DB2-BD59-A6C34878D82A}">
-                    <a16:rowId xmlns:a16="http://schemas.microsoft.com/office/drawing/2014/main" val="10000"/>
-                  </a:ext>
-                </a:extLst>
               </a:tr>
               <a:tr h="600075">
                 <a:tc>
@@ -22620,11 +22015,6 @@
                     </a:solidFill>
                   </a:tcPr>
                 </a:tc>
-                <a:extLst>
-                  <a:ext uri="{0D108BD9-81ED-4DB2-BD59-A6C34878D82A}">
-                    <a16:rowId xmlns:a16="http://schemas.microsoft.com/office/drawing/2014/main" val="10001"/>
-                  </a:ext>
-                </a:extLst>
               </a:tr>
               <a:tr h="600075">
                 <a:tc>
@@ -22693,11 +22083,6 @@
                     </a:solidFill>
                   </a:tcPr>
                 </a:tc>
-                <a:extLst>
-                  <a:ext uri="{0D108BD9-81ED-4DB2-BD59-A6C34878D82A}">
-                    <a16:rowId xmlns:a16="http://schemas.microsoft.com/office/drawing/2014/main" val="10002"/>
-                  </a:ext>
-                </a:extLst>
               </a:tr>
               <a:tr h="600075">
                 <a:tc>
@@ -22766,11 +22151,6 @@
                     </a:solidFill>
                   </a:tcPr>
                 </a:tc>
-                <a:extLst>
-                  <a:ext uri="{0D108BD9-81ED-4DB2-BD59-A6C34878D82A}">
-                    <a16:rowId xmlns:a16="http://schemas.microsoft.com/office/drawing/2014/main" val="10003"/>
-                  </a:ext>
-                </a:extLst>
               </a:tr>
               <a:tr h="600075">
                 <a:tc>
@@ -22839,11 +22219,6 @@
                     </a:solidFill>
                   </a:tcPr>
                 </a:tc>
-                <a:extLst>
-                  <a:ext uri="{0D108BD9-81ED-4DB2-BD59-A6C34878D82A}">
-                    <a16:rowId xmlns:a16="http://schemas.microsoft.com/office/drawing/2014/main" val="10004"/>
-                  </a:ext>
-                </a:extLst>
               </a:tr>
               <a:tr h="600075">
                 <a:tc>
@@ -22912,11 +22287,6 @@
                     </a:solidFill>
                   </a:tcPr>
                 </a:tc>
-                <a:extLst>
-                  <a:ext uri="{0D108BD9-81ED-4DB2-BD59-A6C34878D82A}">
-                    <a16:rowId xmlns:a16="http://schemas.microsoft.com/office/drawing/2014/main" val="10005"/>
-                  </a:ext>
-                </a:extLst>
               </a:tr>
               <a:tr h="600075">
                 <a:tc>
@@ -22985,11 +22355,6 @@
                     </a:solidFill>
                   </a:tcPr>
                 </a:tc>
-                <a:extLst>
-                  <a:ext uri="{0D108BD9-81ED-4DB2-BD59-A6C34878D82A}">
-                    <a16:rowId xmlns:a16="http://schemas.microsoft.com/office/drawing/2014/main" val="10006"/>
-                  </a:ext>
-                </a:extLst>
               </a:tr>
               <a:tr h="600075">
                 <a:tc>
@@ -23058,11 +22423,6 @@
                     </a:solidFill>
                   </a:tcPr>
                 </a:tc>
-                <a:extLst>
-                  <a:ext uri="{0D108BD9-81ED-4DB2-BD59-A6C34878D82A}">
-                    <a16:rowId xmlns:a16="http://schemas.microsoft.com/office/drawing/2014/main" val="10007"/>
-                  </a:ext>
-                </a:extLst>
               </a:tr>
             </a:tbl>
           </a:graphicData>
@@ -23108,7 +22468,6 @@
           <a:lstStyle/>
           <a:p>
             <a:pPr algn="ctr"/>
-            <a:endParaRPr/>
           </a:p>
         </p:txBody>
       </p:sp>
@@ -23152,7 +22511,6 @@
           <a:lstStyle/>
           <a:p>
             <a:pPr algn="ctr"/>
-            <a:endParaRPr/>
           </a:p>
         </p:txBody>
       </p:sp>
@@ -23196,7 +22554,6 @@
           <a:lstStyle/>
           <a:p>
             <a:pPr algn="ctr"/>
-            <a:endParaRPr/>
           </a:p>
         </p:txBody>
       </p:sp>
@@ -23240,7 +22597,6 @@
           <a:lstStyle/>
           <a:p>
             <a:pPr algn="ctr"/>
-            <a:endParaRPr/>
           </a:p>
         </p:txBody>
       </p:sp>
@@ -23284,7 +22640,6 @@
           <a:lstStyle/>
           <a:p>
             <a:pPr algn="ctr"/>
-            <a:endParaRPr/>
           </a:p>
         </p:txBody>
       </p:sp>
@@ -23328,7 +22683,6 @@
           <a:lstStyle/>
           <a:p>
             <a:pPr algn="ctr"/>
-            <a:endParaRPr/>
           </a:p>
         </p:txBody>
       </p:sp>
@@ -23372,7 +22726,6 @@
           <a:lstStyle/>
           <a:p>
             <a:pPr algn="ctr"/>
-            <a:endParaRPr/>
           </a:p>
         </p:txBody>
       </p:sp>
@@ -23455,7 +22808,7 @@
 </file>
 
 <file path=ppt/slides/slide9.xml><?xml version="1.0" encoding="utf-8"?>
-<p:sld xmlns:a="http://schemas.openxmlformats.org/drawingml/2006/main" xmlns:r="http://schemas.openxmlformats.org/officeDocument/2006/relationships" xmlns:p="http://schemas.openxmlformats.org/presentationml/2006/main">
+<p:sld xmlns:a="http://schemas.openxmlformats.org/drawingml/2006/main" xmlns:p="http://schemas.openxmlformats.org/presentationml/2006/main" xmlns:r="http://schemas.openxmlformats.org/officeDocument/2006/relationships">
   <p:cSld>
     <p:bg>
       <p:bgPr>
@@ -23471,14 +22824,7 @@
         <p:cNvGrpSpPr/>
         <p:nvPr/>
       </p:nvGrpSpPr>
-      <p:grpSpPr>
-        <a:xfrm>
-          <a:off x="0" y="0"/>
-          <a:ext cx="0" cy="0"/>
-          <a:chOff x="0" y="0"/>
-          <a:chExt cx="0" cy="0"/>
-        </a:xfrm>
-      </p:grpSpPr>
+      <p:grpSpPr/>
       <p:sp>
         <p:nvSpPr>
           <p:cNvPr id="2" name="TextBox 1"/>
@@ -23554,7 +22900,6 @@
           <a:lstStyle/>
           <a:p>
             <a:pPr algn="ctr"/>
-            <a:endParaRPr/>
           </a:p>
         </p:txBody>
       </p:sp>
@@ -23612,27 +22957,9 @@
                 <a:tableStyleId>{5C22544A-7EE6-4342-B048-85BDC9FD1C3A}</a:tableStyleId>
               </a:tblPr>
               <a:tblGrid>
-                <a:gridCol w="1554480">
-                  <a:extLst>
-                    <a:ext uri="{9D8B030D-6E8A-4147-A177-3AD203B41FA5}">
-                      <a16:colId xmlns:a16="http://schemas.microsoft.com/office/drawing/2014/main" val="20000"/>
-                    </a:ext>
-                  </a:extLst>
-                </a:gridCol>
-                <a:gridCol w="4480560">
-                  <a:extLst>
-                    <a:ext uri="{9D8B030D-6E8A-4147-A177-3AD203B41FA5}">
-                      <a16:colId xmlns:a16="http://schemas.microsoft.com/office/drawing/2014/main" val="20001"/>
-                    </a:ext>
-                  </a:extLst>
-                </a:gridCol>
-                <a:gridCol w="4800600">
-                  <a:extLst>
-                    <a:ext uri="{9D8B030D-6E8A-4147-A177-3AD203B41FA5}">
-                      <a16:colId xmlns:a16="http://schemas.microsoft.com/office/drawing/2014/main" val="20002"/>
-                    </a:ext>
-                  </a:extLst>
-                </a:gridCol>
+                <a:gridCol w="1554480"/>
+                <a:gridCol w="4480560"/>
+                <a:gridCol w="4800600"/>
               </a:tblGrid>
               <a:tr h="667512">
                 <a:tc>
@@ -23701,11 +23028,6 @@
                     </a:solidFill>
                   </a:tcPr>
                 </a:tc>
-                <a:extLst>
-                  <a:ext uri="{0D108BD9-81ED-4DB2-BD59-A6C34878D82A}">
-                    <a16:rowId xmlns:a16="http://schemas.microsoft.com/office/drawing/2014/main" val="10000"/>
-                  </a:ext>
-                </a:extLst>
               </a:tr>
               <a:tr h="667512">
                 <a:tc>
@@ -23774,11 +23096,6 @@
                     </a:solidFill>
                   </a:tcPr>
                 </a:tc>
-                <a:extLst>
-                  <a:ext uri="{0D108BD9-81ED-4DB2-BD59-A6C34878D82A}">
-                    <a16:rowId xmlns:a16="http://schemas.microsoft.com/office/drawing/2014/main" val="10001"/>
-                  </a:ext>
-                </a:extLst>
               </a:tr>
               <a:tr h="667512">
                 <a:tc>
@@ -23847,11 +23164,6 @@
                     </a:solidFill>
                   </a:tcPr>
                 </a:tc>
-                <a:extLst>
-                  <a:ext uri="{0D108BD9-81ED-4DB2-BD59-A6C34878D82A}">
-                    <a16:rowId xmlns:a16="http://schemas.microsoft.com/office/drawing/2014/main" val="10002"/>
-                  </a:ext>
-                </a:extLst>
               </a:tr>
               <a:tr h="667512">
                 <a:tc>
@@ -23920,11 +23232,6 @@
                     </a:solidFill>
                   </a:tcPr>
                 </a:tc>
-                <a:extLst>
-                  <a:ext uri="{0D108BD9-81ED-4DB2-BD59-A6C34878D82A}">
-                    <a16:rowId xmlns:a16="http://schemas.microsoft.com/office/drawing/2014/main" val="10003"/>
-                  </a:ext>
-                </a:extLst>
               </a:tr>
               <a:tr h="667512">
                 <a:tc>
@@ -23993,11 +23300,6 @@
                     </a:solidFill>
                   </a:tcPr>
                 </a:tc>
-                <a:extLst>
-                  <a:ext uri="{0D108BD9-81ED-4DB2-BD59-A6C34878D82A}">
-                    <a16:rowId xmlns:a16="http://schemas.microsoft.com/office/drawing/2014/main" val="10004"/>
-                  </a:ext>
-                </a:extLst>
               </a:tr>
             </a:tbl>
           </a:graphicData>
@@ -24045,7 +23347,6 @@
           <a:lstStyle/>
           <a:p>
             <a:pPr algn="ctr"/>
-            <a:endParaRPr/>
           </a:p>
         </p:txBody>
       </p:sp>
@@ -24159,7 +23460,6 @@
           <a:lstStyle/>
           <a:p>
             <a:pPr algn="ctr"/>
-            <a:endParaRPr/>
           </a:p>
         </p:txBody>
       </p:sp>
@@ -24203,7 +23503,6 @@
           <a:lstStyle/>
           <a:p>
             <a:pPr algn="ctr"/>
-            <a:endParaRPr/>
           </a:p>
         </p:txBody>
       </p:sp>
@@ -24247,7 +23546,6 @@
           <a:lstStyle/>
           <a:p>
             <a:pPr algn="ctr"/>
-            <a:endParaRPr/>
           </a:p>
         </p:txBody>
       </p:sp>
@@ -24291,7 +23589,6 @@
           <a:lstStyle/>
           <a:p>
             <a:pPr algn="ctr"/>
-            <a:endParaRPr/>
           </a:p>
         </p:txBody>
       </p:sp>
@@ -24335,7 +23632,6 @@
           <a:lstStyle/>
           <a:p>
             <a:pPr algn="ctr"/>
-            <a:endParaRPr/>
           </a:p>
         </p:txBody>
       </p:sp>
@@ -24379,7 +23675,6 @@
           <a:lstStyle/>
           <a:p>
             <a:pPr algn="ctr"/>
-            <a:endParaRPr/>
           </a:p>
         </p:txBody>
       </p:sp>
@@ -24423,7 +23718,6 @@
           <a:lstStyle/>
           <a:p>
             <a:pPr algn="ctr"/>
-            <a:endParaRPr/>
           </a:p>
         </p:txBody>
       </p:sp>

</xml_diff>